<commit_message>
docs: resync figure numbering from Drive decks (2026-07-30)
Pulled Fig MyM, Fig R1, Fig R2 (updated) and Fig R3 (new deck) from Drive.
Reviewed all slides (text via markitdown, embedded images via python-pptx)
against docs/mapping_figuras.csv - content-to-slug correspondence is
unchanged for every slide in all four decks, so no numero_actual values
or figures/ folders needed updating this round.

Notes:
- Fig MyM slide 13 (shape_especificidad_tisular, M13) now has an embedded
  image/comment where before it was an empty placeholder - same slug/number,
  just newly populated content.
- Fig R3 is a first-time pull (file didn't exist locally before): slide 1
  (5 images) matches ruido_cgi_tata (R3.1), slide 2 (1 image) matches
  ruido_summary (R3.2). Slide 3 is an empty placeholder ("#", no images) -
  left unmatched rather than forcing it onto R3.3; R3.4 has no corresponding
  slide yet in this deck.
</commit_message>
<xml_diff>
--- a/docs/Fig MyM.pptx
+++ b/docs/Fig MyM.pptx
@@ -9633,26 +9633,56 @@
           <a:chExt cx="0" cy="0"/>
         </a:xfrm>
       </p:grpSpPr>
+      <p:pic>
+        <p:nvPicPr>
+          <p:cNvPr id="190" name="Google Shape;190;p25" title="shape_especificidad_tisular.jpg"/>
+          <p:cNvPicPr preferRelativeResize="0"/>
+          <p:nvPr/>
+        </p:nvPicPr>
+        <p:blipFill>
+          <a:blip r:embed="rId3">
+            <a:alphaModFix/>
+          </a:blip>
+          <a:stretch>
+            <a:fillRect/>
+          </a:stretch>
+        </p:blipFill>
+        <p:spPr>
+          <a:xfrm>
+            <a:off x="271600" y="113528"/>
+            <a:ext cx="8739174" cy="3746597"/>
+          </a:xfrm>
+          <a:prstGeom prst="rect">
+            <a:avLst/>
+          </a:prstGeom>
+          <a:noFill/>
+          <a:ln>
+            <a:noFill/>
+          </a:ln>
+        </p:spPr>
+      </p:pic>
       <p:sp>
         <p:nvSpPr>
-          <p:cNvPr id="190" name="Google Shape;190;p25"/>
+          <p:cNvPr id="191" name="Google Shape;191;p25"/>
           <p:cNvSpPr txBox="1"/>
-          <p:nvPr>
-            <p:ph type="title"/>
-          </p:nvPr>
+          <p:nvPr/>
         </p:nvSpPr>
         <p:spPr>
           <a:xfrm>
-            <a:off x="311700" y="445025"/>
-            <a:ext cx="8520600" cy="572700"/>
+            <a:off x="463225" y="4345400"/>
+            <a:ext cx="5775300" cy="1293000"/>
           </a:xfrm>
           <a:prstGeom prst="rect">
             <a:avLst/>
           </a:prstGeom>
+          <a:noFill/>
+          <a:ln>
+            <a:noFill/>
+          </a:ln>
         </p:spPr>
         <p:txBody>
           <a:bodyPr anchorCtr="0" anchor="t" bIns="91425" lIns="91425" spcFirstLastPara="1" rIns="91425" wrap="square" tIns="91425">
-            <a:normAutofit fontScale="90000"/>
+            <a:spAutoFit/>
           </a:bodyPr>
           <a:lstStyle/>
           <a:p>
@@ -9666,49 +9696,34 @@
               <a:buNone/>
             </a:pPr>
             <a:r>
-              <a:rPr lang="es-419"/>
-              <a:t>shape y tissue specific</a:t>
-            </a:r>
-            <a:endParaRPr/>
-          </a:p>
-        </p:txBody>
-      </p:sp>
-      <p:sp>
-        <p:nvSpPr>
-          <p:cNvPr id="191" name="Google Shape;191;p25"/>
-          <p:cNvSpPr txBox="1"/>
-          <p:nvPr>
-            <p:ph idx="1" type="body"/>
-          </p:nvPr>
-        </p:nvSpPr>
-        <p:spPr>
-          <a:xfrm>
-            <a:off x="311700" y="1152475"/>
-            <a:ext cx="8520600" cy="3416400"/>
-          </a:xfrm>
-          <a:prstGeom prst="rect">
-            <a:avLst/>
-          </a:prstGeom>
-        </p:spPr>
-        <p:txBody>
-          <a:bodyPr anchorCtr="0" anchor="t" bIns="91425" lIns="91425" spcFirstLastPara="1" rIns="91425" wrap="square" tIns="91425">
-            <a:normAutofit/>
-          </a:bodyPr>
-          <a:lstStyle/>
-          <a:p>
-            <a:pPr indent="0" lvl="0" marL="0" rtl="0" algn="l">
-              <a:spcBef>
-                <a:spcPts val="0"/>
-              </a:spcBef>
-              <a:spcAft>
-                <a:spcPts val="1200"/>
-              </a:spcAft>
-              <a:buNone/>
-            </a:pPr>
-            <a:r>
-              <a:t/>
-            </a:r>
-            <a:endParaRPr/>
+              <a:rPr lang="es-419" sz="1800">
+                <a:solidFill>
+                  <a:schemeClr val="dk2"/>
+                </a:solidFill>
+              </a:rPr>
+              <a:t>eventualmente podria agregar un diagrama para mostrar mas claro que es shape. o un heatmap de los ontology con algunos promotores </a:t>
+            </a:r>
+            <a:r>
+              <a:rPr lang="es-419" sz="1800">
+                <a:solidFill>
+                  <a:schemeClr val="dk2"/>
+                </a:solidFill>
+              </a:rPr>
+              <a:t>para</a:t>
+            </a:r>
+            <a:r>
+              <a:rPr lang="es-419" sz="1800">
+                <a:solidFill>
+                  <a:schemeClr val="dk2"/>
+                </a:solidFill>
+              </a:rPr>
+              <a:t> mostrar tissue specificity</a:t>
+            </a:r>
+            <a:endParaRPr sz="1800">
+              <a:solidFill>
+                <a:schemeClr val="dk2"/>
+              </a:solidFill>
+            </a:endParaRPr>
           </a:p>
         </p:txBody>
       </p:sp>
@@ -12438,6 +12453,285 @@
 </file>
 
 <file path=ppt/theme/theme1.xml><?xml version="1.0" encoding="utf-8"?>
+<a:theme xmlns:a="http://schemas.openxmlformats.org/drawingml/2006/main" xmlns:r="http://schemas.openxmlformats.org/officeDocument/2006/relationships" name="Simple Light">
+  <a:themeElements>
+    <a:clrScheme name="Simple Light">
+      <a:dk1>
+        <a:srgbClr val="000000"/>
+      </a:dk1>
+      <a:lt1>
+        <a:srgbClr val="FFFFFF"/>
+      </a:lt1>
+      <a:dk2>
+        <a:srgbClr val="595959"/>
+      </a:dk2>
+      <a:lt2>
+        <a:srgbClr val="EEEEEE"/>
+      </a:lt2>
+      <a:accent1>
+        <a:srgbClr val="4285F4"/>
+      </a:accent1>
+      <a:accent2>
+        <a:srgbClr val="212121"/>
+      </a:accent2>
+      <a:accent3>
+        <a:srgbClr val="78909C"/>
+      </a:accent3>
+      <a:accent4>
+        <a:srgbClr val="FFAB40"/>
+      </a:accent4>
+      <a:accent5>
+        <a:srgbClr val="0097A7"/>
+      </a:accent5>
+      <a:accent6>
+        <a:srgbClr val="EEFF41"/>
+      </a:accent6>
+      <a:hlink>
+        <a:srgbClr val="0097A7"/>
+      </a:hlink>
+      <a:folHlink>
+        <a:srgbClr val="0097A7"/>
+      </a:folHlink>
+    </a:clrScheme>
+    <a:fontScheme name="Office">
+      <a:majorFont>
+        <a:latin typeface="Arial"/>
+        <a:ea typeface=""/>
+        <a:cs typeface=""/>
+        <a:font script="Jpan" typeface="ＭＳ Ｐゴシック"/>
+        <a:font script="Hang" typeface="맑은 고딕"/>
+        <a:font script="Hans" typeface="宋体"/>
+        <a:font script="Hant" typeface="新細明體"/>
+        <a:font script="Arab" typeface="Times New Roman"/>
+        <a:font script="Hebr" typeface="Times New Roman"/>
+        <a:font script="Thai" typeface="Angsana New"/>
+        <a:font script="Ethi" typeface="Nyala"/>
+        <a:font script="Beng" typeface="Vrinda"/>
+        <a:font script="Gujr" typeface="Shruti"/>
+        <a:font script="Khmr" typeface="MoolBoran"/>
+        <a:font script="Knda" typeface="Tunga"/>
+        <a:font script="Guru" typeface="Raavi"/>
+        <a:font script="Cans" typeface="Euphemia"/>
+        <a:font script="Cher" typeface="Plantagenet Cherokee"/>
+        <a:font script="Yiii" typeface="Microsoft Yi Baiti"/>
+        <a:font script="Tibt" typeface="Microsoft Himalaya"/>
+        <a:font script="Thaa" typeface="MV Boli"/>
+        <a:font script="Deva" typeface="Mangal"/>
+        <a:font script="Telu" typeface="Gautami"/>
+        <a:font script="Taml" typeface="Latha"/>
+        <a:font script="Syrc" typeface="Estrangelo Edessa"/>
+        <a:font script="Orya" typeface="Kalinga"/>
+        <a:font script="Mlym" typeface="Kartika"/>
+        <a:font script="Laoo" typeface="DokChampa"/>
+        <a:font script="Sinh" typeface="Iskoola Pota"/>
+        <a:font script="Mong" typeface="Mongolian Baiti"/>
+        <a:font script="Viet" typeface="Times New Roman"/>
+        <a:font script="Uigh" typeface="Microsoft Uighur"/>
+        <a:font script="Geor" typeface="Sylfaen"/>
+      </a:majorFont>
+      <a:minorFont>
+        <a:latin typeface="Arial"/>
+        <a:ea typeface=""/>
+        <a:cs typeface=""/>
+        <a:font script="Jpan" typeface="ＭＳ Ｐゴシック"/>
+        <a:font script="Hang" typeface="맑은 고딕"/>
+        <a:font script="Hans" typeface="宋体"/>
+        <a:font script="Hant" typeface="新細明體"/>
+        <a:font script="Arab" typeface="Arial"/>
+        <a:font script="Hebr" typeface="Arial"/>
+        <a:font script="Thai" typeface="Cordia New"/>
+        <a:font script="Ethi" typeface="Nyala"/>
+        <a:font script="Beng" typeface="Vrinda"/>
+        <a:font script="Gujr" typeface="Shruti"/>
+        <a:font script="Khmr" typeface="DaunPenh"/>
+        <a:font script="Knda" typeface="Tunga"/>
+        <a:font script="Guru" typeface="Raavi"/>
+        <a:font script="Cans" typeface="Euphemia"/>
+        <a:font script="Cher" typeface="Plantagenet Cherokee"/>
+        <a:font script="Yiii" typeface="Microsoft Yi Baiti"/>
+        <a:font script="Tibt" typeface="Microsoft Himalaya"/>
+        <a:font script="Thaa" typeface="MV Boli"/>
+        <a:font script="Deva" typeface="Mangal"/>
+        <a:font script="Telu" typeface="Gautami"/>
+        <a:font script="Taml" typeface="Latha"/>
+        <a:font script="Syrc" typeface="Estrangelo Edessa"/>
+        <a:font script="Orya" typeface="Kalinga"/>
+        <a:font script="Mlym" typeface="Kartika"/>
+        <a:font script="Laoo" typeface="DokChampa"/>
+        <a:font script="Sinh" typeface="Iskoola Pota"/>
+        <a:font script="Mong" typeface="Mongolian Baiti"/>
+        <a:font script="Viet" typeface="Arial"/>
+        <a:font script="Uigh" typeface="Microsoft Uighur"/>
+        <a:font script="Geor" typeface="Sylfaen"/>
+      </a:minorFont>
+    </a:fontScheme>
+    <a:fmtScheme name="Office">
+      <a:fillStyleLst>
+        <a:solidFill>
+          <a:schemeClr val="phClr"/>
+        </a:solidFill>
+        <a:gradFill rotWithShape="1">
+          <a:gsLst>
+            <a:gs pos="0">
+              <a:schemeClr val="phClr">
+                <a:tint val="50000"/>
+                <a:satMod val="300000"/>
+              </a:schemeClr>
+            </a:gs>
+            <a:gs pos="35000">
+              <a:schemeClr val="phClr">
+                <a:tint val="37000"/>
+                <a:satMod val="300000"/>
+              </a:schemeClr>
+            </a:gs>
+            <a:gs pos="100000">
+              <a:schemeClr val="phClr">
+                <a:tint val="15000"/>
+                <a:satMod val="350000"/>
+              </a:schemeClr>
+            </a:gs>
+          </a:gsLst>
+          <a:lin ang="16200000" scaled="1"/>
+        </a:gradFill>
+        <a:gradFill rotWithShape="1">
+          <a:gsLst>
+            <a:gs pos="0">
+              <a:schemeClr val="phClr">
+                <a:tint val="100000"/>
+                <a:shade val="100000"/>
+                <a:satMod val="130000"/>
+              </a:schemeClr>
+            </a:gs>
+            <a:gs pos="100000">
+              <a:schemeClr val="phClr">
+                <a:tint val="50000"/>
+                <a:shade val="100000"/>
+                <a:satMod val="350000"/>
+              </a:schemeClr>
+            </a:gs>
+          </a:gsLst>
+          <a:lin ang="16200000" scaled="0"/>
+        </a:gradFill>
+      </a:fillStyleLst>
+      <a:lnStyleLst>
+        <a:ln w="9525" cap="flat" cmpd="sng" algn="ctr">
+          <a:solidFill>
+            <a:schemeClr val="phClr">
+              <a:shade val="95000"/>
+              <a:satMod val="105000"/>
+            </a:schemeClr>
+          </a:solidFill>
+          <a:prstDash val="solid"/>
+        </a:ln>
+        <a:ln w="25400" cap="flat" cmpd="sng" algn="ctr">
+          <a:solidFill>
+            <a:schemeClr val="phClr"/>
+          </a:solidFill>
+          <a:prstDash val="solid"/>
+        </a:ln>
+        <a:ln w="38100" cap="flat" cmpd="sng" algn="ctr">
+          <a:solidFill>
+            <a:schemeClr val="phClr"/>
+          </a:solidFill>
+          <a:prstDash val="solid"/>
+        </a:ln>
+      </a:lnStyleLst>
+      <a:effectStyleLst>
+        <a:effectStyle>
+          <a:effectLst>
+            <a:outerShdw blurRad="40000" dist="20000" dir="5400000" rotWithShape="0">
+              <a:srgbClr val="000000">
+                <a:alpha val="38000"/>
+              </a:srgbClr>
+            </a:outerShdw>
+          </a:effectLst>
+        </a:effectStyle>
+        <a:effectStyle>
+          <a:effectLst>
+            <a:outerShdw blurRad="40000" dist="23000" dir="5400000" rotWithShape="0">
+              <a:srgbClr val="000000">
+                <a:alpha val="35000"/>
+              </a:srgbClr>
+            </a:outerShdw>
+          </a:effectLst>
+        </a:effectStyle>
+        <a:effectStyle>
+          <a:effectLst>
+            <a:outerShdw blurRad="40000" dist="23000" dir="5400000" rotWithShape="0">
+              <a:srgbClr val="000000">
+                <a:alpha val="35000"/>
+              </a:srgbClr>
+            </a:outerShdw>
+          </a:effectLst>
+          <a:scene3d>
+            <a:camera prst="orthographicFront">
+              <a:rot lat="0" lon="0" rev="0"/>
+            </a:camera>
+            <a:lightRig rig="threePt" dir="t">
+              <a:rot lat="0" lon="0" rev="1200000"/>
+            </a:lightRig>
+          </a:scene3d>
+          <a:sp3d>
+            <a:bevelT w="63500" h="25400"/>
+          </a:sp3d>
+        </a:effectStyle>
+      </a:effectStyleLst>
+      <a:bgFillStyleLst>
+        <a:solidFill>
+          <a:schemeClr val="phClr"/>
+        </a:solidFill>
+        <a:gradFill rotWithShape="1">
+          <a:gsLst>
+            <a:gs pos="0">
+              <a:schemeClr val="phClr">
+                <a:tint val="40000"/>
+                <a:satMod val="350000"/>
+              </a:schemeClr>
+            </a:gs>
+            <a:gs pos="40000">
+              <a:schemeClr val="phClr">
+                <a:tint val="45000"/>
+                <a:shade val="99000"/>
+                <a:satMod val="350000"/>
+              </a:schemeClr>
+            </a:gs>
+            <a:gs pos="100000">
+              <a:schemeClr val="phClr">
+                <a:shade val="20000"/>
+                <a:satMod val="255000"/>
+              </a:schemeClr>
+            </a:gs>
+          </a:gsLst>
+          <a:path path="circle">
+            <a:fillToRect l="50000" t="-80000" r="50000" b="180000"/>
+          </a:path>
+        </a:gradFill>
+        <a:gradFill rotWithShape="1">
+          <a:gsLst>
+            <a:gs pos="0">
+              <a:schemeClr val="phClr">
+                <a:tint val="80000"/>
+                <a:satMod val="300000"/>
+              </a:schemeClr>
+            </a:gs>
+            <a:gs pos="100000">
+              <a:schemeClr val="phClr">
+                <a:shade val="30000"/>
+                <a:satMod val="200000"/>
+              </a:schemeClr>
+            </a:gs>
+          </a:gsLst>
+          <a:path path="circle">
+            <a:fillToRect l="50000" t="50000" r="50000" b="50000"/>
+          </a:path>
+        </a:gradFill>
+      </a:bgFillStyleLst>
+    </a:fmtScheme>
+  </a:themeElements>
+</a:theme>
+</file>
+
+<file path=ppt/theme/theme2.xml><?xml version="1.0" encoding="utf-8"?>
 <a:theme xmlns:a="http://schemas.openxmlformats.org/drawingml/2006/main" xmlns:r="http://schemas.openxmlformats.org/officeDocument/2006/relationships">
   <a:themeElements>
     <a:clrScheme name="Default">
@@ -12714,283 +13008,4 @@
     </a:fmtScheme>
   </a:themeElements>
 </a:theme>
-</file>
-
-<file path=ppt/theme/theme2.xml><?xml version="1.0" encoding="utf-8"?>
-<a:theme xmlns:a="http://schemas.openxmlformats.org/drawingml/2006/main" xmlns:r="http://schemas.openxmlformats.org/officeDocument/2006/relationships" name="Simple Light">
-  <a:themeElements>
-    <a:clrScheme name="Simple Light">
-      <a:dk1>
-        <a:srgbClr val="000000"/>
-      </a:dk1>
-      <a:lt1>
-        <a:srgbClr val="FFFFFF"/>
-      </a:lt1>
-      <a:dk2>
-        <a:srgbClr val="595959"/>
-      </a:dk2>
-      <a:lt2>
-        <a:srgbClr val="EEEEEE"/>
-      </a:lt2>
-      <a:accent1>
-        <a:srgbClr val="4285F4"/>
-      </a:accent1>
-      <a:accent2>
-        <a:srgbClr val="212121"/>
-      </a:accent2>
-      <a:accent3>
-        <a:srgbClr val="78909C"/>
-      </a:accent3>
-      <a:accent4>
-        <a:srgbClr val="FFAB40"/>
-      </a:accent4>
-      <a:accent5>
-        <a:srgbClr val="0097A7"/>
-      </a:accent5>
-      <a:accent6>
-        <a:srgbClr val="EEFF41"/>
-      </a:accent6>
-      <a:hlink>
-        <a:srgbClr val="0097A7"/>
-      </a:hlink>
-      <a:folHlink>
-        <a:srgbClr val="0097A7"/>
-      </a:folHlink>
-    </a:clrScheme>
-    <a:fontScheme name="Office">
-      <a:majorFont>
-        <a:latin typeface="Arial"/>
-        <a:ea typeface=""/>
-        <a:cs typeface=""/>
-        <a:font script="Jpan" typeface="ＭＳ Ｐゴシック"/>
-        <a:font script="Hang" typeface="맑은 고딕"/>
-        <a:font script="Hans" typeface="宋体"/>
-        <a:font script="Hant" typeface="新細明體"/>
-        <a:font script="Arab" typeface="Times New Roman"/>
-        <a:font script="Hebr" typeface="Times New Roman"/>
-        <a:font script="Thai" typeface="Angsana New"/>
-        <a:font script="Ethi" typeface="Nyala"/>
-        <a:font script="Beng" typeface="Vrinda"/>
-        <a:font script="Gujr" typeface="Shruti"/>
-        <a:font script="Khmr" typeface="MoolBoran"/>
-        <a:font script="Knda" typeface="Tunga"/>
-        <a:font script="Guru" typeface="Raavi"/>
-        <a:font script="Cans" typeface="Euphemia"/>
-        <a:font script="Cher" typeface="Plantagenet Cherokee"/>
-        <a:font script="Yiii" typeface="Microsoft Yi Baiti"/>
-        <a:font script="Tibt" typeface="Microsoft Himalaya"/>
-        <a:font script="Thaa" typeface="MV Boli"/>
-        <a:font script="Deva" typeface="Mangal"/>
-        <a:font script="Telu" typeface="Gautami"/>
-        <a:font script="Taml" typeface="Latha"/>
-        <a:font script="Syrc" typeface="Estrangelo Edessa"/>
-        <a:font script="Orya" typeface="Kalinga"/>
-        <a:font script="Mlym" typeface="Kartika"/>
-        <a:font script="Laoo" typeface="DokChampa"/>
-        <a:font script="Sinh" typeface="Iskoola Pota"/>
-        <a:font script="Mong" typeface="Mongolian Baiti"/>
-        <a:font script="Viet" typeface="Times New Roman"/>
-        <a:font script="Uigh" typeface="Microsoft Uighur"/>
-        <a:font script="Geor" typeface="Sylfaen"/>
-      </a:majorFont>
-      <a:minorFont>
-        <a:latin typeface="Arial"/>
-        <a:ea typeface=""/>
-        <a:cs typeface=""/>
-        <a:font script="Jpan" typeface="ＭＳ Ｐゴシック"/>
-        <a:font script="Hang" typeface="맑은 고딕"/>
-        <a:font script="Hans" typeface="宋体"/>
-        <a:font script="Hant" typeface="新細明體"/>
-        <a:font script="Arab" typeface="Arial"/>
-        <a:font script="Hebr" typeface="Arial"/>
-        <a:font script="Thai" typeface="Cordia New"/>
-        <a:font script="Ethi" typeface="Nyala"/>
-        <a:font script="Beng" typeface="Vrinda"/>
-        <a:font script="Gujr" typeface="Shruti"/>
-        <a:font script="Khmr" typeface="DaunPenh"/>
-        <a:font script="Knda" typeface="Tunga"/>
-        <a:font script="Guru" typeface="Raavi"/>
-        <a:font script="Cans" typeface="Euphemia"/>
-        <a:font script="Cher" typeface="Plantagenet Cherokee"/>
-        <a:font script="Yiii" typeface="Microsoft Yi Baiti"/>
-        <a:font script="Tibt" typeface="Microsoft Himalaya"/>
-        <a:font script="Thaa" typeface="MV Boli"/>
-        <a:font script="Deva" typeface="Mangal"/>
-        <a:font script="Telu" typeface="Gautami"/>
-        <a:font script="Taml" typeface="Latha"/>
-        <a:font script="Syrc" typeface="Estrangelo Edessa"/>
-        <a:font script="Orya" typeface="Kalinga"/>
-        <a:font script="Mlym" typeface="Kartika"/>
-        <a:font script="Laoo" typeface="DokChampa"/>
-        <a:font script="Sinh" typeface="Iskoola Pota"/>
-        <a:font script="Mong" typeface="Mongolian Baiti"/>
-        <a:font script="Viet" typeface="Arial"/>
-        <a:font script="Uigh" typeface="Microsoft Uighur"/>
-        <a:font script="Geor" typeface="Sylfaen"/>
-      </a:minorFont>
-    </a:fontScheme>
-    <a:fmtScheme name="Office">
-      <a:fillStyleLst>
-        <a:solidFill>
-          <a:schemeClr val="phClr"/>
-        </a:solidFill>
-        <a:gradFill rotWithShape="1">
-          <a:gsLst>
-            <a:gs pos="0">
-              <a:schemeClr val="phClr">
-                <a:tint val="50000"/>
-                <a:satMod val="300000"/>
-              </a:schemeClr>
-            </a:gs>
-            <a:gs pos="35000">
-              <a:schemeClr val="phClr">
-                <a:tint val="37000"/>
-                <a:satMod val="300000"/>
-              </a:schemeClr>
-            </a:gs>
-            <a:gs pos="100000">
-              <a:schemeClr val="phClr">
-                <a:tint val="15000"/>
-                <a:satMod val="350000"/>
-              </a:schemeClr>
-            </a:gs>
-          </a:gsLst>
-          <a:lin ang="16200000" scaled="1"/>
-        </a:gradFill>
-        <a:gradFill rotWithShape="1">
-          <a:gsLst>
-            <a:gs pos="0">
-              <a:schemeClr val="phClr">
-                <a:tint val="100000"/>
-                <a:shade val="100000"/>
-                <a:satMod val="130000"/>
-              </a:schemeClr>
-            </a:gs>
-            <a:gs pos="100000">
-              <a:schemeClr val="phClr">
-                <a:tint val="50000"/>
-                <a:shade val="100000"/>
-                <a:satMod val="350000"/>
-              </a:schemeClr>
-            </a:gs>
-          </a:gsLst>
-          <a:lin ang="16200000" scaled="0"/>
-        </a:gradFill>
-      </a:fillStyleLst>
-      <a:lnStyleLst>
-        <a:ln w="9525" cap="flat" cmpd="sng" algn="ctr">
-          <a:solidFill>
-            <a:schemeClr val="phClr">
-              <a:shade val="95000"/>
-              <a:satMod val="105000"/>
-            </a:schemeClr>
-          </a:solidFill>
-          <a:prstDash val="solid"/>
-        </a:ln>
-        <a:ln w="25400" cap="flat" cmpd="sng" algn="ctr">
-          <a:solidFill>
-            <a:schemeClr val="phClr"/>
-          </a:solidFill>
-          <a:prstDash val="solid"/>
-        </a:ln>
-        <a:ln w="38100" cap="flat" cmpd="sng" algn="ctr">
-          <a:solidFill>
-            <a:schemeClr val="phClr"/>
-          </a:solidFill>
-          <a:prstDash val="solid"/>
-        </a:ln>
-      </a:lnStyleLst>
-      <a:effectStyleLst>
-        <a:effectStyle>
-          <a:effectLst>
-            <a:outerShdw blurRad="40000" dist="20000" dir="5400000" rotWithShape="0">
-              <a:srgbClr val="000000">
-                <a:alpha val="38000"/>
-              </a:srgbClr>
-            </a:outerShdw>
-          </a:effectLst>
-        </a:effectStyle>
-        <a:effectStyle>
-          <a:effectLst>
-            <a:outerShdw blurRad="40000" dist="23000" dir="5400000" rotWithShape="0">
-              <a:srgbClr val="000000">
-                <a:alpha val="35000"/>
-              </a:srgbClr>
-            </a:outerShdw>
-          </a:effectLst>
-        </a:effectStyle>
-        <a:effectStyle>
-          <a:effectLst>
-            <a:outerShdw blurRad="40000" dist="23000" dir="5400000" rotWithShape="0">
-              <a:srgbClr val="000000">
-                <a:alpha val="35000"/>
-              </a:srgbClr>
-            </a:outerShdw>
-          </a:effectLst>
-          <a:scene3d>
-            <a:camera prst="orthographicFront">
-              <a:rot lat="0" lon="0" rev="0"/>
-            </a:camera>
-            <a:lightRig rig="threePt" dir="t">
-              <a:rot lat="0" lon="0" rev="1200000"/>
-            </a:lightRig>
-          </a:scene3d>
-          <a:sp3d>
-            <a:bevelT w="63500" h="25400"/>
-          </a:sp3d>
-        </a:effectStyle>
-      </a:effectStyleLst>
-      <a:bgFillStyleLst>
-        <a:solidFill>
-          <a:schemeClr val="phClr"/>
-        </a:solidFill>
-        <a:gradFill rotWithShape="1">
-          <a:gsLst>
-            <a:gs pos="0">
-              <a:schemeClr val="phClr">
-                <a:tint val="40000"/>
-                <a:satMod val="350000"/>
-              </a:schemeClr>
-            </a:gs>
-            <a:gs pos="40000">
-              <a:schemeClr val="phClr">
-                <a:tint val="45000"/>
-                <a:shade val="99000"/>
-                <a:satMod val="350000"/>
-              </a:schemeClr>
-            </a:gs>
-            <a:gs pos="100000">
-              <a:schemeClr val="phClr">
-                <a:shade val="20000"/>
-                <a:satMod val="255000"/>
-              </a:schemeClr>
-            </a:gs>
-          </a:gsLst>
-          <a:path path="circle">
-            <a:fillToRect l="50000" t="-80000" r="50000" b="180000"/>
-          </a:path>
-        </a:gradFill>
-        <a:gradFill rotWithShape="1">
-          <a:gsLst>
-            <a:gs pos="0">
-              <a:schemeClr val="phClr">
-                <a:tint val="80000"/>
-                <a:satMod val="300000"/>
-              </a:schemeClr>
-            </a:gs>
-            <a:gs pos="100000">
-              <a:schemeClr val="phClr">
-                <a:shade val="30000"/>
-                <a:satMod val="200000"/>
-              </a:schemeClr>
-            </a:gs>
-          </a:gsLst>
-          <a:path path="circle">
-            <a:fillToRect l="50000" t="50000" r="50000" b="50000"/>
-          </a:path>
-        </a:gradFill>
-      </a:bgFillStyleLst>
-    </a:fmtScheme>
-  </a:themeElements>
-</a:theme>
 </file>
</xml_diff>

<commit_message>
docs: resync figure numbering from Drive decks (2026-07-31)
Pulled Fig MyM, Fig R1, Fig R2, and Fig R3 from Drive - all four changed
at the byte level. Reviewed every slide's content (text via markitdown,
embedded images via python-pptx) against docs/mapping_figuras.csv and
confirmed the slide-to-slug correspondence is unchanged in all four
decks, so no numero_actual updates or figures/ folder renames were
needed this run.
</commit_message>
<xml_diff>
--- a/docs/Fig MyM.pptx
+++ b/docs/Fig MyM.pptx
@@ -12453,6 +12453,285 @@
 </file>
 
 <file path=ppt/theme/theme1.xml><?xml version="1.0" encoding="utf-8"?>
+<a:theme xmlns:a="http://schemas.openxmlformats.org/drawingml/2006/main" xmlns:r="http://schemas.openxmlformats.org/officeDocument/2006/relationships">
+  <a:themeElements>
+    <a:clrScheme name="Default">
+      <a:dk1>
+        <a:srgbClr val="000000"/>
+      </a:dk1>
+      <a:lt1>
+        <a:srgbClr val="FFFFFF"/>
+      </a:lt1>
+      <a:dk2>
+        <a:srgbClr val="158158"/>
+      </a:dk2>
+      <a:lt2>
+        <a:srgbClr val="F3F3F3"/>
+      </a:lt2>
+      <a:accent1>
+        <a:srgbClr val="058DC7"/>
+      </a:accent1>
+      <a:accent2>
+        <a:srgbClr val="50B432"/>
+      </a:accent2>
+      <a:accent3>
+        <a:srgbClr val="ED561B"/>
+      </a:accent3>
+      <a:accent4>
+        <a:srgbClr val="EDEF00"/>
+      </a:accent4>
+      <a:accent5>
+        <a:srgbClr val="24CBE5"/>
+      </a:accent5>
+      <a:accent6>
+        <a:srgbClr val="64E572"/>
+      </a:accent6>
+      <a:hlink>
+        <a:srgbClr val="2200CC"/>
+      </a:hlink>
+      <a:folHlink>
+        <a:srgbClr val="551A8B"/>
+      </a:folHlink>
+    </a:clrScheme>
+    <a:fontScheme name="Office">
+      <a:majorFont>
+        <a:latin typeface="Arial"/>
+        <a:ea typeface=""/>
+        <a:cs typeface=""/>
+        <a:font script="Jpan" typeface="ＭＳ Ｐゴシック"/>
+        <a:font script="Hang" typeface="맑은 고딕"/>
+        <a:font script="Hans" typeface="宋体"/>
+        <a:font script="Hant" typeface="新細明體"/>
+        <a:font script="Arab" typeface="Times New Roman"/>
+        <a:font script="Hebr" typeface="Times New Roman"/>
+        <a:font script="Thai" typeface="Angsana New"/>
+        <a:font script="Ethi" typeface="Nyala"/>
+        <a:font script="Beng" typeface="Vrinda"/>
+        <a:font script="Gujr" typeface="Shruti"/>
+        <a:font script="Khmr" typeface="MoolBoran"/>
+        <a:font script="Knda" typeface="Tunga"/>
+        <a:font script="Guru" typeface="Raavi"/>
+        <a:font script="Cans" typeface="Euphemia"/>
+        <a:font script="Cher" typeface="Plantagenet Cherokee"/>
+        <a:font script="Yiii" typeface="Microsoft Yi Baiti"/>
+        <a:font script="Tibt" typeface="Microsoft Himalaya"/>
+        <a:font script="Thaa" typeface="MV Boli"/>
+        <a:font script="Deva" typeface="Mangal"/>
+        <a:font script="Telu" typeface="Gautami"/>
+        <a:font script="Taml" typeface="Latha"/>
+        <a:font script="Syrc" typeface="Estrangelo Edessa"/>
+        <a:font script="Orya" typeface="Kalinga"/>
+        <a:font script="Mlym" typeface="Kartika"/>
+        <a:font script="Laoo" typeface="DokChampa"/>
+        <a:font script="Sinh" typeface="Iskoola Pota"/>
+        <a:font script="Mong" typeface="Mongolian Baiti"/>
+        <a:font script="Viet" typeface="Times New Roman"/>
+        <a:font script="Uigh" typeface="Microsoft Uighur"/>
+        <a:font script="Geor" typeface="Sylfaen"/>
+      </a:majorFont>
+      <a:minorFont>
+        <a:latin typeface="Arial"/>
+        <a:ea typeface=""/>
+        <a:cs typeface=""/>
+        <a:font script="Jpan" typeface="ＭＳ Ｐゴシック"/>
+        <a:font script="Hang" typeface="맑은 고딕"/>
+        <a:font script="Hans" typeface="宋体"/>
+        <a:font script="Hant" typeface="新細明體"/>
+        <a:font script="Arab" typeface="Arial"/>
+        <a:font script="Hebr" typeface="Arial"/>
+        <a:font script="Thai" typeface="Cordia New"/>
+        <a:font script="Ethi" typeface="Nyala"/>
+        <a:font script="Beng" typeface="Vrinda"/>
+        <a:font script="Gujr" typeface="Shruti"/>
+        <a:font script="Khmr" typeface="DaunPenh"/>
+        <a:font script="Knda" typeface="Tunga"/>
+        <a:font script="Guru" typeface="Raavi"/>
+        <a:font script="Cans" typeface="Euphemia"/>
+        <a:font script="Cher" typeface="Plantagenet Cherokee"/>
+        <a:font script="Yiii" typeface="Microsoft Yi Baiti"/>
+        <a:font script="Tibt" typeface="Microsoft Himalaya"/>
+        <a:font script="Thaa" typeface="MV Boli"/>
+        <a:font script="Deva" typeface="Mangal"/>
+        <a:font script="Telu" typeface="Gautami"/>
+        <a:font script="Taml" typeface="Latha"/>
+        <a:font script="Syrc" typeface="Estrangelo Edessa"/>
+        <a:font script="Orya" typeface="Kalinga"/>
+        <a:font script="Mlym" typeface="Kartika"/>
+        <a:font script="Laoo" typeface="DokChampa"/>
+        <a:font script="Sinh" typeface="Iskoola Pota"/>
+        <a:font script="Mong" typeface="Mongolian Baiti"/>
+        <a:font script="Viet" typeface="Arial"/>
+        <a:font script="Uigh" typeface="Microsoft Uighur"/>
+        <a:font script="Geor" typeface="Sylfaen"/>
+      </a:minorFont>
+    </a:fontScheme>
+    <a:fmtScheme name="Office">
+      <a:fillStyleLst>
+        <a:solidFill>
+          <a:schemeClr val="phClr"/>
+        </a:solidFill>
+        <a:gradFill rotWithShape="1">
+          <a:gsLst>
+            <a:gs pos="0">
+              <a:schemeClr val="phClr">
+                <a:tint val="50000"/>
+                <a:satMod val="300000"/>
+              </a:schemeClr>
+            </a:gs>
+            <a:gs pos="35000">
+              <a:schemeClr val="phClr">
+                <a:tint val="37000"/>
+                <a:satMod val="300000"/>
+              </a:schemeClr>
+            </a:gs>
+            <a:gs pos="100000">
+              <a:schemeClr val="phClr">
+                <a:tint val="15000"/>
+                <a:satMod val="350000"/>
+              </a:schemeClr>
+            </a:gs>
+          </a:gsLst>
+          <a:lin ang="16200000" scaled="1"/>
+        </a:gradFill>
+        <a:gradFill rotWithShape="1">
+          <a:gsLst>
+            <a:gs pos="0">
+              <a:schemeClr val="phClr">
+                <a:tint val="100000"/>
+                <a:shade val="100000"/>
+                <a:satMod val="130000"/>
+              </a:schemeClr>
+            </a:gs>
+            <a:gs pos="100000">
+              <a:schemeClr val="phClr">
+                <a:tint val="50000"/>
+                <a:shade val="100000"/>
+                <a:satMod val="350000"/>
+              </a:schemeClr>
+            </a:gs>
+          </a:gsLst>
+          <a:lin ang="16200000" scaled="0"/>
+        </a:gradFill>
+      </a:fillStyleLst>
+      <a:lnStyleLst>
+        <a:ln w="9525" cap="flat" cmpd="sng" algn="ctr">
+          <a:solidFill>
+            <a:schemeClr val="phClr">
+              <a:shade val="95000"/>
+              <a:satMod val="105000"/>
+            </a:schemeClr>
+          </a:solidFill>
+          <a:prstDash val="solid"/>
+        </a:ln>
+        <a:ln w="25400" cap="flat" cmpd="sng" algn="ctr">
+          <a:solidFill>
+            <a:schemeClr val="phClr"/>
+          </a:solidFill>
+          <a:prstDash val="solid"/>
+        </a:ln>
+        <a:ln w="38100" cap="flat" cmpd="sng" algn="ctr">
+          <a:solidFill>
+            <a:schemeClr val="phClr"/>
+          </a:solidFill>
+          <a:prstDash val="solid"/>
+        </a:ln>
+      </a:lnStyleLst>
+      <a:effectStyleLst>
+        <a:effectStyle>
+          <a:effectLst>
+            <a:outerShdw blurRad="40000" dist="20000" dir="5400000" rotWithShape="0">
+              <a:srgbClr val="000000">
+                <a:alpha val="38000"/>
+              </a:srgbClr>
+            </a:outerShdw>
+          </a:effectLst>
+        </a:effectStyle>
+        <a:effectStyle>
+          <a:effectLst>
+            <a:outerShdw blurRad="40000" dist="23000" dir="5400000" rotWithShape="0">
+              <a:srgbClr val="000000">
+                <a:alpha val="35000"/>
+              </a:srgbClr>
+            </a:outerShdw>
+          </a:effectLst>
+        </a:effectStyle>
+        <a:effectStyle>
+          <a:effectLst>
+            <a:outerShdw blurRad="40000" dist="23000" dir="5400000" rotWithShape="0">
+              <a:srgbClr val="000000">
+                <a:alpha val="35000"/>
+              </a:srgbClr>
+            </a:outerShdw>
+          </a:effectLst>
+          <a:scene3d>
+            <a:camera prst="orthographicFront">
+              <a:rot lat="0" lon="0" rev="0"/>
+            </a:camera>
+            <a:lightRig rig="threePt" dir="t">
+              <a:rot lat="0" lon="0" rev="1200000"/>
+            </a:lightRig>
+          </a:scene3d>
+          <a:sp3d>
+            <a:bevelT w="63500" h="25400"/>
+          </a:sp3d>
+        </a:effectStyle>
+      </a:effectStyleLst>
+      <a:bgFillStyleLst>
+        <a:solidFill>
+          <a:schemeClr val="phClr"/>
+        </a:solidFill>
+        <a:gradFill rotWithShape="1">
+          <a:gsLst>
+            <a:gs pos="0">
+              <a:schemeClr val="phClr">
+                <a:tint val="40000"/>
+                <a:satMod val="350000"/>
+              </a:schemeClr>
+            </a:gs>
+            <a:gs pos="40000">
+              <a:schemeClr val="phClr">
+                <a:tint val="45000"/>
+                <a:shade val="99000"/>
+                <a:satMod val="350000"/>
+              </a:schemeClr>
+            </a:gs>
+            <a:gs pos="100000">
+              <a:schemeClr val="phClr">
+                <a:shade val="20000"/>
+                <a:satMod val="255000"/>
+              </a:schemeClr>
+            </a:gs>
+          </a:gsLst>
+          <a:path path="circle">
+            <a:fillToRect l="50000" t="-80000" r="50000" b="180000"/>
+          </a:path>
+        </a:gradFill>
+        <a:gradFill rotWithShape="1">
+          <a:gsLst>
+            <a:gs pos="0">
+              <a:schemeClr val="phClr">
+                <a:tint val="80000"/>
+                <a:satMod val="300000"/>
+              </a:schemeClr>
+            </a:gs>
+            <a:gs pos="100000">
+              <a:schemeClr val="phClr">
+                <a:shade val="30000"/>
+                <a:satMod val="200000"/>
+              </a:schemeClr>
+            </a:gs>
+          </a:gsLst>
+          <a:path path="circle">
+            <a:fillToRect l="50000" t="50000" r="50000" b="50000"/>
+          </a:path>
+        </a:gradFill>
+      </a:bgFillStyleLst>
+    </a:fmtScheme>
+  </a:themeElements>
+</a:theme>
+</file>
+
+<file path=ppt/theme/theme2.xml><?xml version="1.0" encoding="utf-8"?>
 <a:theme xmlns:a="http://schemas.openxmlformats.org/drawingml/2006/main" xmlns:r="http://schemas.openxmlformats.org/officeDocument/2006/relationships" name="Simple Light">
   <a:themeElements>
     <a:clrScheme name="Simple Light">
@@ -12729,283 +13008,4 @@
     </a:fmtScheme>
   </a:themeElements>
 </a:theme>
-</file>
-
-<file path=ppt/theme/theme2.xml><?xml version="1.0" encoding="utf-8"?>
-<a:theme xmlns:a="http://schemas.openxmlformats.org/drawingml/2006/main" xmlns:r="http://schemas.openxmlformats.org/officeDocument/2006/relationships">
-  <a:themeElements>
-    <a:clrScheme name="Default">
-      <a:dk1>
-        <a:srgbClr val="000000"/>
-      </a:dk1>
-      <a:lt1>
-        <a:srgbClr val="FFFFFF"/>
-      </a:lt1>
-      <a:dk2>
-        <a:srgbClr val="158158"/>
-      </a:dk2>
-      <a:lt2>
-        <a:srgbClr val="F3F3F3"/>
-      </a:lt2>
-      <a:accent1>
-        <a:srgbClr val="058DC7"/>
-      </a:accent1>
-      <a:accent2>
-        <a:srgbClr val="50B432"/>
-      </a:accent2>
-      <a:accent3>
-        <a:srgbClr val="ED561B"/>
-      </a:accent3>
-      <a:accent4>
-        <a:srgbClr val="EDEF00"/>
-      </a:accent4>
-      <a:accent5>
-        <a:srgbClr val="24CBE5"/>
-      </a:accent5>
-      <a:accent6>
-        <a:srgbClr val="64E572"/>
-      </a:accent6>
-      <a:hlink>
-        <a:srgbClr val="2200CC"/>
-      </a:hlink>
-      <a:folHlink>
-        <a:srgbClr val="551A8B"/>
-      </a:folHlink>
-    </a:clrScheme>
-    <a:fontScheme name="Office">
-      <a:majorFont>
-        <a:latin typeface="Arial"/>
-        <a:ea typeface=""/>
-        <a:cs typeface=""/>
-        <a:font script="Jpan" typeface="ＭＳ Ｐゴシック"/>
-        <a:font script="Hang" typeface="맑은 고딕"/>
-        <a:font script="Hans" typeface="宋体"/>
-        <a:font script="Hant" typeface="新細明體"/>
-        <a:font script="Arab" typeface="Times New Roman"/>
-        <a:font script="Hebr" typeface="Times New Roman"/>
-        <a:font script="Thai" typeface="Angsana New"/>
-        <a:font script="Ethi" typeface="Nyala"/>
-        <a:font script="Beng" typeface="Vrinda"/>
-        <a:font script="Gujr" typeface="Shruti"/>
-        <a:font script="Khmr" typeface="MoolBoran"/>
-        <a:font script="Knda" typeface="Tunga"/>
-        <a:font script="Guru" typeface="Raavi"/>
-        <a:font script="Cans" typeface="Euphemia"/>
-        <a:font script="Cher" typeface="Plantagenet Cherokee"/>
-        <a:font script="Yiii" typeface="Microsoft Yi Baiti"/>
-        <a:font script="Tibt" typeface="Microsoft Himalaya"/>
-        <a:font script="Thaa" typeface="MV Boli"/>
-        <a:font script="Deva" typeface="Mangal"/>
-        <a:font script="Telu" typeface="Gautami"/>
-        <a:font script="Taml" typeface="Latha"/>
-        <a:font script="Syrc" typeface="Estrangelo Edessa"/>
-        <a:font script="Orya" typeface="Kalinga"/>
-        <a:font script="Mlym" typeface="Kartika"/>
-        <a:font script="Laoo" typeface="DokChampa"/>
-        <a:font script="Sinh" typeface="Iskoola Pota"/>
-        <a:font script="Mong" typeface="Mongolian Baiti"/>
-        <a:font script="Viet" typeface="Times New Roman"/>
-        <a:font script="Uigh" typeface="Microsoft Uighur"/>
-        <a:font script="Geor" typeface="Sylfaen"/>
-      </a:majorFont>
-      <a:minorFont>
-        <a:latin typeface="Arial"/>
-        <a:ea typeface=""/>
-        <a:cs typeface=""/>
-        <a:font script="Jpan" typeface="ＭＳ Ｐゴシック"/>
-        <a:font script="Hang" typeface="맑은 고딕"/>
-        <a:font script="Hans" typeface="宋体"/>
-        <a:font script="Hant" typeface="新細明體"/>
-        <a:font script="Arab" typeface="Arial"/>
-        <a:font script="Hebr" typeface="Arial"/>
-        <a:font script="Thai" typeface="Cordia New"/>
-        <a:font script="Ethi" typeface="Nyala"/>
-        <a:font script="Beng" typeface="Vrinda"/>
-        <a:font script="Gujr" typeface="Shruti"/>
-        <a:font script="Khmr" typeface="DaunPenh"/>
-        <a:font script="Knda" typeface="Tunga"/>
-        <a:font script="Guru" typeface="Raavi"/>
-        <a:font script="Cans" typeface="Euphemia"/>
-        <a:font script="Cher" typeface="Plantagenet Cherokee"/>
-        <a:font script="Yiii" typeface="Microsoft Yi Baiti"/>
-        <a:font script="Tibt" typeface="Microsoft Himalaya"/>
-        <a:font script="Thaa" typeface="MV Boli"/>
-        <a:font script="Deva" typeface="Mangal"/>
-        <a:font script="Telu" typeface="Gautami"/>
-        <a:font script="Taml" typeface="Latha"/>
-        <a:font script="Syrc" typeface="Estrangelo Edessa"/>
-        <a:font script="Orya" typeface="Kalinga"/>
-        <a:font script="Mlym" typeface="Kartika"/>
-        <a:font script="Laoo" typeface="DokChampa"/>
-        <a:font script="Sinh" typeface="Iskoola Pota"/>
-        <a:font script="Mong" typeface="Mongolian Baiti"/>
-        <a:font script="Viet" typeface="Arial"/>
-        <a:font script="Uigh" typeface="Microsoft Uighur"/>
-        <a:font script="Geor" typeface="Sylfaen"/>
-      </a:minorFont>
-    </a:fontScheme>
-    <a:fmtScheme name="Office">
-      <a:fillStyleLst>
-        <a:solidFill>
-          <a:schemeClr val="phClr"/>
-        </a:solidFill>
-        <a:gradFill rotWithShape="1">
-          <a:gsLst>
-            <a:gs pos="0">
-              <a:schemeClr val="phClr">
-                <a:tint val="50000"/>
-                <a:satMod val="300000"/>
-              </a:schemeClr>
-            </a:gs>
-            <a:gs pos="35000">
-              <a:schemeClr val="phClr">
-                <a:tint val="37000"/>
-                <a:satMod val="300000"/>
-              </a:schemeClr>
-            </a:gs>
-            <a:gs pos="100000">
-              <a:schemeClr val="phClr">
-                <a:tint val="15000"/>
-                <a:satMod val="350000"/>
-              </a:schemeClr>
-            </a:gs>
-          </a:gsLst>
-          <a:lin ang="16200000" scaled="1"/>
-        </a:gradFill>
-        <a:gradFill rotWithShape="1">
-          <a:gsLst>
-            <a:gs pos="0">
-              <a:schemeClr val="phClr">
-                <a:tint val="100000"/>
-                <a:shade val="100000"/>
-                <a:satMod val="130000"/>
-              </a:schemeClr>
-            </a:gs>
-            <a:gs pos="100000">
-              <a:schemeClr val="phClr">
-                <a:tint val="50000"/>
-                <a:shade val="100000"/>
-                <a:satMod val="350000"/>
-              </a:schemeClr>
-            </a:gs>
-          </a:gsLst>
-          <a:lin ang="16200000" scaled="0"/>
-        </a:gradFill>
-      </a:fillStyleLst>
-      <a:lnStyleLst>
-        <a:ln w="9525" cap="flat" cmpd="sng" algn="ctr">
-          <a:solidFill>
-            <a:schemeClr val="phClr">
-              <a:shade val="95000"/>
-              <a:satMod val="105000"/>
-            </a:schemeClr>
-          </a:solidFill>
-          <a:prstDash val="solid"/>
-        </a:ln>
-        <a:ln w="25400" cap="flat" cmpd="sng" algn="ctr">
-          <a:solidFill>
-            <a:schemeClr val="phClr"/>
-          </a:solidFill>
-          <a:prstDash val="solid"/>
-        </a:ln>
-        <a:ln w="38100" cap="flat" cmpd="sng" algn="ctr">
-          <a:solidFill>
-            <a:schemeClr val="phClr"/>
-          </a:solidFill>
-          <a:prstDash val="solid"/>
-        </a:ln>
-      </a:lnStyleLst>
-      <a:effectStyleLst>
-        <a:effectStyle>
-          <a:effectLst>
-            <a:outerShdw blurRad="40000" dist="20000" dir="5400000" rotWithShape="0">
-              <a:srgbClr val="000000">
-                <a:alpha val="38000"/>
-              </a:srgbClr>
-            </a:outerShdw>
-          </a:effectLst>
-        </a:effectStyle>
-        <a:effectStyle>
-          <a:effectLst>
-            <a:outerShdw blurRad="40000" dist="23000" dir="5400000" rotWithShape="0">
-              <a:srgbClr val="000000">
-                <a:alpha val="35000"/>
-              </a:srgbClr>
-            </a:outerShdw>
-          </a:effectLst>
-        </a:effectStyle>
-        <a:effectStyle>
-          <a:effectLst>
-            <a:outerShdw blurRad="40000" dist="23000" dir="5400000" rotWithShape="0">
-              <a:srgbClr val="000000">
-                <a:alpha val="35000"/>
-              </a:srgbClr>
-            </a:outerShdw>
-          </a:effectLst>
-          <a:scene3d>
-            <a:camera prst="orthographicFront">
-              <a:rot lat="0" lon="0" rev="0"/>
-            </a:camera>
-            <a:lightRig rig="threePt" dir="t">
-              <a:rot lat="0" lon="0" rev="1200000"/>
-            </a:lightRig>
-          </a:scene3d>
-          <a:sp3d>
-            <a:bevelT w="63500" h="25400"/>
-          </a:sp3d>
-        </a:effectStyle>
-      </a:effectStyleLst>
-      <a:bgFillStyleLst>
-        <a:solidFill>
-          <a:schemeClr val="phClr"/>
-        </a:solidFill>
-        <a:gradFill rotWithShape="1">
-          <a:gsLst>
-            <a:gs pos="0">
-              <a:schemeClr val="phClr">
-                <a:tint val="40000"/>
-                <a:satMod val="350000"/>
-              </a:schemeClr>
-            </a:gs>
-            <a:gs pos="40000">
-              <a:schemeClr val="phClr">
-                <a:tint val="45000"/>
-                <a:shade val="99000"/>
-                <a:satMod val="350000"/>
-              </a:schemeClr>
-            </a:gs>
-            <a:gs pos="100000">
-              <a:schemeClr val="phClr">
-                <a:shade val="20000"/>
-                <a:satMod val="255000"/>
-              </a:schemeClr>
-            </a:gs>
-          </a:gsLst>
-          <a:path path="circle">
-            <a:fillToRect l="50000" t="-80000" r="50000" b="180000"/>
-          </a:path>
-        </a:gradFill>
-        <a:gradFill rotWithShape="1">
-          <a:gsLst>
-            <a:gs pos="0">
-              <a:schemeClr val="phClr">
-                <a:tint val="80000"/>
-                <a:satMod val="300000"/>
-              </a:schemeClr>
-            </a:gs>
-            <a:gs pos="100000">
-              <a:schemeClr val="phClr">
-                <a:shade val="30000"/>
-                <a:satMod val="200000"/>
-              </a:schemeClr>
-            </a:gs>
-          </a:gsLst>
-          <a:path path="circle">
-            <a:fillToRect l="50000" t="50000" r="50000" b="50000"/>
-          </a:path>
-        </a:gradFill>
-      </a:bgFillStyleLst>
-    </a:fmtScheme>
-  </a:themeElements>
-</a:theme>
 </file>
</xml_diff>

<commit_message>
docs: resync figure numbering from Drive decks (2026-08-03)
Refreshed docs/Fig MyM.pptx, Fig R1.pptx, Fig R2.pptx, Fig R3.pptx from
Drive. All four decks re-exported with new file bytes but identical
slide text, notes, and embedded images to the previously committed
versions - no figure content or ordering actually changed, so
docs/mapping_figuras.csv is untouched.
</commit_message>
<xml_diff>
--- a/docs/Fig MyM.pptx
+++ b/docs/Fig MyM.pptx
@@ -52,7 +52,7 @@
         <a:srgbClr val="000000"/>
       </a:buClr>
       <a:buFont typeface="Arial"/>
-      <a:defRPr b="0" i="0" sz="1400" u="none" cap="none" strike="noStrike">
+      <a:defRPr b="0" i="0" spc="0" sz="1400" u="none" cap="none" strike="noStrike">
         <a:solidFill>
           <a:srgbClr val="000000"/>
         </a:solidFill>
@@ -76,7 +76,7 @@
         <a:srgbClr val="000000"/>
       </a:buClr>
       <a:buFont typeface="Arial"/>
-      <a:defRPr b="0" i="0" sz="1400" u="none" cap="none" strike="noStrike">
+      <a:defRPr b="0" i="0" spc="0" sz="1400" u="none" cap="none" strike="noStrike">
         <a:solidFill>
           <a:srgbClr val="000000"/>
         </a:solidFill>
@@ -100,7 +100,7 @@
         <a:srgbClr val="000000"/>
       </a:buClr>
       <a:buFont typeface="Arial"/>
-      <a:defRPr b="0" i="0" sz="1400" u="none" cap="none" strike="noStrike">
+      <a:defRPr b="0" i="0" spc="0" sz="1400" u="none" cap="none" strike="noStrike">
         <a:solidFill>
           <a:srgbClr val="000000"/>
         </a:solidFill>
@@ -124,7 +124,7 @@
         <a:srgbClr val="000000"/>
       </a:buClr>
       <a:buFont typeface="Arial"/>
-      <a:defRPr b="0" i="0" sz="1400" u="none" cap="none" strike="noStrike">
+      <a:defRPr b="0" i="0" spc="0" sz="1400" u="none" cap="none" strike="noStrike">
         <a:solidFill>
           <a:srgbClr val="000000"/>
         </a:solidFill>
@@ -148,7 +148,7 @@
         <a:srgbClr val="000000"/>
       </a:buClr>
       <a:buFont typeface="Arial"/>
-      <a:defRPr b="0" i="0" sz="1400" u="none" cap="none" strike="noStrike">
+      <a:defRPr b="0" i="0" spc="0" sz="1400" u="none" cap="none" strike="noStrike">
         <a:solidFill>
           <a:srgbClr val="000000"/>
         </a:solidFill>
@@ -172,7 +172,7 @@
         <a:srgbClr val="000000"/>
       </a:buClr>
       <a:buFont typeface="Arial"/>
-      <a:defRPr b="0" i="0" sz="1400" u="none" cap="none" strike="noStrike">
+      <a:defRPr b="0" i="0" spc="0" sz="1400" u="none" cap="none" strike="noStrike">
         <a:solidFill>
           <a:srgbClr val="000000"/>
         </a:solidFill>
@@ -196,7 +196,7 @@
         <a:srgbClr val="000000"/>
       </a:buClr>
       <a:buFont typeface="Arial"/>
-      <a:defRPr b="0" i="0" sz="1400" u="none" cap="none" strike="noStrike">
+      <a:defRPr b="0" i="0" spc="0" sz="1400" u="none" cap="none" strike="noStrike">
         <a:solidFill>
           <a:srgbClr val="000000"/>
         </a:solidFill>
@@ -220,7 +220,7 @@
         <a:srgbClr val="000000"/>
       </a:buClr>
       <a:buFont typeface="Arial"/>
-      <a:defRPr b="0" i="0" sz="1400" u="none" cap="none" strike="noStrike">
+      <a:defRPr b="0" i="0" spc="0" sz="1400" u="none" cap="none" strike="noStrike">
         <a:solidFill>
           <a:srgbClr val="000000"/>
         </a:solidFill>
@@ -244,7 +244,7 @@
         <a:srgbClr val="000000"/>
       </a:buClr>
       <a:buFont typeface="Arial"/>
-      <a:defRPr b="0" i="0" sz="1400" u="none" cap="none" strike="noStrike">
+      <a:defRPr b="0" i="0" spc="0" sz="1400" u="none" cap="none" strike="noStrike">
         <a:solidFill>
           <a:srgbClr val="000000"/>
         </a:solidFill>
@@ -527,7 +527,7 @@
         <a:srgbClr val="000000"/>
       </a:buClr>
       <a:buFont typeface="Arial"/>
-      <a:defRPr b="0" i="0" sz="1400" u="none" cap="none" strike="noStrike">
+      <a:defRPr b="0" i="0" spc="0" sz="1400" u="none" cap="none" strike="noStrike">
         <a:solidFill>
           <a:srgbClr val="000000"/>
         </a:solidFill>
@@ -551,7 +551,7 @@
         <a:srgbClr val="000000"/>
       </a:buClr>
       <a:buFont typeface="Arial"/>
-      <a:defRPr b="0" i="0" sz="1400" u="none" cap="none" strike="noStrike">
+      <a:defRPr b="0" i="0" spc="0" sz="1400" u="none" cap="none" strike="noStrike">
         <a:solidFill>
           <a:srgbClr val="000000"/>
         </a:solidFill>
@@ -575,7 +575,7 @@
         <a:srgbClr val="000000"/>
       </a:buClr>
       <a:buFont typeface="Arial"/>
-      <a:defRPr b="0" i="0" sz="1400" u="none" cap="none" strike="noStrike">
+      <a:defRPr b="0" i="0" spc="0" sz="1400" u="none" cap="none" strike="noStrike">
         <a:solidFill>
           <a:srgbClr val="000000"/>
         </a:solidFill>
@@ -599,7 +599,7 @@
         <a:srgbClr val="000000"/>
       </a:buClr>
       <a:buFont typeface="Arial"/>
-      <a:defRPr b="0" i="0" sz="1400" u="none" cap="none" strike="noStrike">
+      <a:defRPr b="0" i="0" spc="0" sz="1400" u="none" cap="none" strike="noStrike">
         <a:solidFill>
           <a:srgbClr val="000000"/>
         </a:solidFill>
@@ -623,7 +623,7 @@
         <a:srgbClr val="000000"/>
       </a:buClr>
       <a:buFont typeface="Arial"/>
-      <a:defRPr b="0" i="0" sz="1400" u="none" cap="none" strike="noStrike">
+      <a:defRPr b="0" i="0" spc="0" sz="1400" u="none" cap="none" strike="noStrike">
         <a:solidFill>
           <a:srgbClr val="000000"/>
         </a:solidFill>
@@ -647,7 +647,7 @@
         <a:srgbClr val="000000"/>
       </a:buClr>
       <a:buFont typeface="Arial"/>
-      <a:defRPr b="0" i="0" sz="1400" u="none" cap="none" strike="noStrike">
+      <a:defRPr b="0" i="0" spc="0" sz="1400" u="none" cap="none" strike="noStrike">
         <a:solidFill>
           <a:srgbClr val="000000"/>
         </a:solidFill>
@@ -671,7 +671,7 @@
         <a:srgbClr val="000000"/>
       </a:buClr>
       <a:buFont typeface="Arial"/>
-      <a:defRPr b="0" i="0" sz="1400" u="none" cap="none" strike="noStrike">
+      <a:defRPr b="0" i="0" spc="0" sz="1400" u="none" cap="none" strike="noStrike">
         <a:solidFill>
           <a:srgbClr val="000000"/>
         </a:solidFill>
@@ -695,7 +695,7 @@
         <a:srgbClr val="000000"/>
       </a:buClr>
       <a:buFont typeface="Arial"/>
-      <a:defRPr b="0" i="0" sz="1400" u="none" cap="none" strike="noStrike">
+      <a:defRPr b="0" i="0" spc="0" sz="1400" u="none" cap="none" strike="noStrike">
         <a:solidFill>
           <a:srgbClr val="000000"/>
         </a:solidFill>
@@ -719,7 +719,7 @@
         <a:srgbClr val="000000"/>
       </a:buClr>
       <a:buFont typeface="Arial"/>
-      <a:defRPr b="0" i="0" sz="1400" u="none" cap="none" strike="noStrike">
+      <a:defRPr b="0" i="0" spc="0" sz="1400" u="none" cap="none" strike="noStrike">
         <a:solidFill>
           <a:srgbClr val="000000"/>
         </a:solidFill>
@@ -6202,7 +6202,7 @@
           <a:srgbClr val="000000"/>
         </a:buClr>
         <a:buFont typeface="Arial"/>
-        <a:defRPr b="0" i="0" sz="1400" u="none" cap="none" strike="noStrike">
+        <a:defRPr b="0" i="0" spc="0" sz="1400" u="none" cap="none" strike="noStrike">
           <a:solidFill>
             <a:srgbClr val="000000"/>
           </a:solidFill>
@@ -6226,7 +6226,7 @@
           <a:srgbClr val="000000"/>
         </a:buClr>
         <a:buFont typeface="Arial"/>
-        <a:defRPr b="0" i="0" sz="1400" u="none" cap="none" strike="noStrike">
+        <a:defRPr b="0" i="0" spc="0" sz="1400" u="none" cap="none" strike="noStrike">
           <a:solidFill>
             <a:srgbClr val="000000"/>
           </a:solidFill>
@@ -6250,7 +6250,7 @@
           <a:srgbClr val="000000"/>
         </a:buClr>
         <a:buFont typeface="Arial"/>
-        <a:defRPr b="0" i="0" sz="1400" u="none" cap="none" strike="noStrike">
+        <a:defRPr b="0" i="0" spc="0" sz="1400" u="none" cap="none" strike="noStrike">
           <a:solidFill>
             <a:srgbClr val="000000"/>
           </a:solidFill>
@@ -6274,7 +6274,7 @@
           <a:srgbClr val="000000"/>
         </a:buClr>
         <a:buFont typeface="Arial"/>
-        <a:defRPr b="0" i="0" sz="1400" u="none" cap="none" strike="noStrike">
+        <a:defRPr b="0" i="0" spc="0" sz="1400" u="none" cap="none" strike="noStrike">
           <a:solidFill>
             <a:srgbClr val="000000"/>
           </a:solidFill>
@@ -6298,7 +6298,7 @@
           <a:srgbClr val="000000"/>
         </a:buClr>
         <a:buFont typeface="Arial"/>
-        <a:defRPr b="0" i="0" sz="1400" u="none" cap="none" strike="noStrike">
+        <a:defRPr b="0" i="0" spc="0" sz="1400" u="none" cap="none" strike="noStrike">
           <a:solidFill>
             <a:srgbClr val="000000"/>
           </a:solidFill>
@@ -6322,7 +6322,7 @@
           <a:srgbClr val="000000"/>
         </a:buClr>
         <a:buFont typeface="Arial"/>
-        <a:defRPr b="0" i="0" sz="1400" u="none" cap="none" strike="noStrike">
+        <a:defRPr b="0" i="0" spc="0" sz="1400" u="none" cap="none" strike="noStrike">
           <a:solidFill>
             <a:srgbClr val="000000"/>
           </a:solidFill>
@@ -6346,7 +6346,7 @@
           <a:srgbClr val="000000"/>
         </a:buClr>
         <a:buFont typeface="Arial"/>
-        <a:defRPr b="0" i="0" sz="1400" u="none" cap="none" strike="noStrike">
+        <a:defRPr b="0" i="0" spc="0" sz="1400" u="none" cap="none" strike="noStrike">
           <a:solidFill>
             <a:srgbClr val="000000"/>
           </a:solidFill>
@@ -6370,7 +6370,7 @@
           <a:srgbClr val="000000"/>
         </a:buClr>
         <a:buFont typeface="Arial"/>
-        <a:defRPr b="0" i="0" sz="1400" u="none" cap="none" strike="noStrike">
+        <a:defRPr b="0" i="0" spc="0" sz="1400" u="none" cap="none" strike="noStrike">
           <a:solidFill>
             <a:srgbClr val="000000"/>
           </a:solidFill>
@@ -6394,7 +6394,7 @@
           <a:srgbClr val="000000"/>
         </a:buClr>
         <a:buFont typeface="Arial"/>
-        <a:defRPr b="0" i="0" sz="1400" u="none" cap="none" strike="noStrike">
+        <a:defRPr b="0" i="0" spc="0" sz="1400" u="none" cap="none" strike="noStrike">
           <a:solidFill>
             <a:srgbClr val="000000"/>
           </a:solidFill>
@@ -6431,7 +6431,7 @@
           <a:srgbClr val="000000"/>
         </a:buClr>
         <a:buFont typeface="Arial"/>
-        <a:defRPr b="0" i="0" sz="1400" u="none" cap="none" strike="noStrike">
+        <a:defRPr b="0" i="0" spc="0" sz="1400" u="none" cap="none" strike="noStrike">
           <a:solidFill>
             <a:srgbClr val="000000"/>
           </a:solidFill>
@@ -6455,7 +6455,7 @@
           <a:srgbClr val="000000"/>
         </a:buClr>
         <a:buFont typeface="Arial"/>
-        <a:defRPr b="0" i="0" sz="1400" u="none" cap="none" strike="noStrike">
+        <a:defRPr b="0" i="0" spc="0" sz="1400" u="none" cap="none" strike="noStrike">
           <a:solidFill>
             <a:srgbClr val="000000"/>
           </a:solidFill>
@@ -6479,7 +6479,7 @@
           <a:srgbClr val="000000"/>
         </a:buClr>
         <a:buFont typeface="Arial"/>
-        <a:defRPr b="0" i="0" sz="1400" u="none" cap="none" strike="noStrike">
+        <a:defRPr b="0" i="0" spc="0" sz="1400" u="none" cap="none" strike="noStrike">
           <a:solidFill>
             <a:srgbClr val="000000"/>
           </a:solidFill>
@@ -6503,7 +6503,7 @@
           <a:srgbClr val="000000"/>
         </a:buClr>
         <a:buFont typeface="Arial"/>
-        <a:defRPr b="0" i="0" sz="1400" u="none" cap="none" strike="noStrike">
+        <a:defRPr b="0" i="0" spc="0" sz="1400" u="none" cap="none" strike="noStrike">
           <a:solidFill>
             <a:srgbClr val="000000"/>
           </a:solidFill>
@@ -6527,7 +6527,7 @@
           <a:srgbClr val="000000"/>
         </a:buClr>
         <a:buFont typeface="Arial"/>
-        <a:defRPr b="0" i="0" sz="1400" u="none" cap="none" strike="noStrike">
+        <a:defRPr b="0" i="0" spc="0" sz="1400" u="none" cap="none" strike="noStrike">
           <a:solidFill>
             <a:srgbClr val="000000"/>
           </a:solidFill>
@@ -6551,7 +6551,7 @@
           <a:srgbClr val="000000"/>
         </a:buClr>
         <a:buFont typeface="Arial"/>
-        <a:defRPr b="0" i="0" sz="1400" u="none" cap="none" strike="noStrike">
+        <a:defRPr b="0" i="0" spc="0" sz="1400" u="none" cap="none" strike="noStrike">
           <a:solidFill>
             <a:srgbClr val="000000"/>
           </a:solidFill>
@@ -6575,7 +6575,7 @@
           <a:srgbClr val="000000"/>
         </a:buClr>
         <a:buFont typeface="Arial"/>
-        <a:defRPr b="0" i="0" sz="1400" u="none" cap="none" strike="noStrike">
+        <a:defRPr b="0" i="0" spc="0" sz="1400" u="none" cap="none" strike="noStrike">
           <a:solidFill>
             <a:srgbClr val="000000"/>
           </a:solidFill>
@@ -6599,7 +6599,7 @@
           <a:srgbClr val="000000"/>
         </a:buClr>
         <a:buFont typeface="Arial"/>
-        <a:defRPr b="0" i="0" sz="1400" u="none" cap="none" strike="noStrike">
+        <a:defRPr b="0" i="0" spc="0" sz="1400" u="none" cap="none" strike="noStrike">
           <a:solidFill>
             <a:srgbClr val="000000"/>
           </a:solidFill>
@@ -6623,7 +6623,7 @@
           <a:srgbClr val="000000"/>
         </a:buClr>
         <a:buFont typeface="Arial"/>
-        <a:defRPr b="0" i="0" sz="1400" u="none" cap="none" strike="noStrike">
+        <a:defRPr b="0" i="0" spc="0" sz="1400" u="none" cap="none" strike="noStrike">
           <a:solidFill>
             <a:srgbClr val="000000"/>
           </a:solidFill>
@@ -6660,7 +6660,7 @@
           <a:srgbClr val="000000"/>
         </a:buClr>
         <a:buFont typeface="Arial"/>
-        <a:defRPr b="0" i="0" sz="1400" u="none" cap="none" strike="noStrike">
+        <a:defRPr b="0" i="0" spc="0" sz="1400" u="none" cap="none" strike="noStrike">
           <a:solidFill>
             <a:srgbClr val="000000"/>
           </a:solidFill>
@@ -6684,7 +6684,7 @@
           <a:srgbClr val="000000"/>
         </a:buClr>
         <a:buFont typeface="Arial"/>
-        <a:defRPr b="0" i="0" sz="1400" u="none" cap="none" strike="noStrike">
+        <a:defRPr b="0" i="0" spc="0" sz="1400" u="none" cap="none" strike="noStrike">
           <a:solidFill>
             <a:srgbClr val="000000"/>
           </a:solidFill>
@@ -6708,7 +6708,7 @@
           <a:srgbClr val="000000"/>
         </a:buClr>
         <a:buFont typeface="Arial"/>
-        <a:defRPr b="0" i="0" sz="1400" u="none" cap="none" strike="noStrike">
+        <a:defRPr b="0" i="0" spc="0" sz="1400" u="none" cap="none" strike="noStrike">
           <a:solidFill>
             <a:srgbClr val="000000"/>
           </a:solidFill>
@@ -6732,7 +6732,7 @@
           <a:srgbClr val="000000"/>
         </a:buClr>
         <a:buFont typeface="Arial"/>
-        <a:defRPr b="0" i="0" sz="1400" u="none" cap="none" strike="noStrike">
+        <a:defRPr b="0" i="0" spc="0" sz="1400" u="none" cap="none" strike="noStrike">
           <a:solidFill>
             <a:srgbClr val="000000"/>
           </a:solidFill>
@@ -6756,7 +6756,7 @@
           <a:srgbClr val="000000"/>
         </a:buClr>
         <a:buFont typeface="Arial"/>
-        <a:defRPr b="0" i="0" sz="1400" u="none" cap="none" strike="noStrike">
+        <a:defRPr b="0" i="0" spc="0" sz="1400" u="none" cap="none" strike="noStrike">
           <a:solidFill>
             <a:srgbClr val="000000"/>
           </a:solidFill>
@@ -6780,7 +6780,7 @@
           <a:srgbClr val="000000"/>
         </a:buClr>
         <a:buFont typeface="Arial"/>
-        <a:defRPr b="0" i="0" sz="1400" u="none" cap="none" strike="noStrike">
+        <a:defRPr b="0" i="0" spc="0" sz="1400" u="none" cap="none" strike="noStrike">
           <a:solidFill>
             <a:srgbClr val="000000"/>
           </a:solidFill>
@@ -6804,7 +6804,7 @@
           <a:srgbClr val="000000"/>
         </a:buClr>
         <a:buFont typeface="Arial"/>
-        <a:defRPr b="0" i="0" sz="1400" u="none" cap="none" strike="noStrike">
+        <a:defRPr b="0" i="0" spc="0" sz="1400" u="none" cap="none" strike="noStrike">
           <a:solidFill>
             <a:srgbClr val="000000"/>
           </a:solidFill>
@@ -6828,7 +6828,7 @@
           <a:srgbClr val="000000"/>
         </a:buClr>
         <a:buFont typeface="Arial"/>
-        <a:defRPr b="0" i="0" sz="1400" u="none" cap="none" strike="noStrike">
+        <a:defRPr b="0" i="0" spc="0" sz="1400" u="none" cap="none" strike="noStrike">
           <a:solidFill>
             <a:srgbClr val="000000"/>
           </a:solidFill>
@@ -6852,7 +6852,7 @@
           <a:srgbClr val="000000"/>
         </a:buClr>
         <a:buFont typeface="Arial"/>
-        <a:defRPr b="0" i="0" sz="1400" u="none" cap="none" strike="noStrike">
+        <a:defRPr b="0" i="0" spc="0" sz="1400" u="none" cap="none" strike="noStrike">
           <a:solidFill>
             <a:srgbClr val="000000"/>
           </a:solidFill>

</xml_diff>

<commit_message>
docs: resync figure numbering from Drive decks (2026-08-11)
Re-pulled Fig MyM, Fig R1, Fig R2, Fig R3 from Drive. All four
re-exported with different image compression bytes, but slide text
content is byte-identical to the previously committed versions and no
new/moved/removed slides were found - no numero_actual changes needed
in docs/mapping_figuras.csv.
</commit_message>
<xml_diff>
--- a/docs/Fig MyM.pptx
+++ b/docs/Fig MyM.pptx
@@ -12453,6 +12453,285 @@
 </file>
 
 <file path=ppt/theme/theme1.xml><?xml version="1.0" encoding="utf-8"?>
+<a:theme xmlns:a="http://schemas.openxmlformats.org/drawingml/2006/main" xmlns:r="http://schemas.openxmlformats.org/officeDocument/2006/relationships" name="Simple Light">
+  <a:themeElements>
+    <a:clrScheme name="Simple Light">
+      <a:dk1>
+        <a:srgbClr val="000000"/>
+      </a:dk1>
+      <a:lt1>
+        <a:srgbClr val="FFFFFF"/>
+      </a:lt1>
+      <a:dk2>
+        <a:srgbClr val="595959"/>
+      </a:dk2>
+      <a:lt2>
+        <a:srgbClr val="EEEEEE"/>
+      </a:lt2>
+      <a:accent1>
+        <a:srgbClr val="4285F4"/>
+      </a:accent1>
+      <a:accent2>
+        <a:srgbClr val="212121"/>
+      </a:accent2>
+      <a:accent3>
+        <a:srgbClr val="78909C"/>
+      </a:accent3>
+      <a:accent4>
+        <a:srgbClr val="FFAB40"/>
+      </a:accent4>
+      <a:accent5>
+        <a:srgbClr val="0097A7"/>
+      </a:accent5>
+      <a:accent6>
+        <a:srgbClr val="EEFF41"/>
+      </a:accent6>
+      <a:hlink>
+        <a:srgbClr val="0097A7"/>
+      </a:hlink>
+      <a:folHlink>
+        <a:srgbClr val="0097A7"/>
+      </a:folHlink>
+    </a:clrScheme>
+    <a:fontScheme name="Office">
+      <a:majorFont>
+        <a:latin typeface="Arial"/>
+        <a:ea typeface=""/>
+        <a:cs typeface=""/>
+        <a:font script="Jpan" typeface="ＭＳ Ｐゴシック"/>
+        <a:font script="Hang" typeface="맑은 고딕"/>
+        <a:font script="Hans" typeface="宋体"/>
+        <a:font script="Hant" typeface="新細明體"/>
+        <a:font script="Arab" typeface="Times New Roman"/>
+        <a:font script="Hebr" typeface="Times New Roman"/>
+        <a:font script="Thai" typeface="Angsana New"/>
+        <a:font script="Ethi" typeface="Nyala"/>
+        <a:font script="Beng" typeface="Vrinda"/>
+        <a:font script="Gujr" typeface="Shruti"/>
+        <a:font script="Khmr" typeface="MoolBoran"/>
+        <a:font script="Knda" typeface="Tunga"/>
+        <a:font script="Guru" typeface="Raavi"/>
+        <a:font script="Cans" typeface="Euphemia"/>
+        <a:font script="Cher" typeface="Plantagenet Cherokee"/>
+        <a:font script="Yiii" typeface="Microsoft Yi Baiti"/>
+        <a:font script="Tibt" typeface="Microsoft Himalaya"/>
+        <a:font script="Thaa" typeface="MV Boli"/>
+        <a:font script="Deva" typeface="Mangal"/>
+        <a:font script="Telu" typeface="Gautami"/>
+        <a:font script="Taml" typeface="Latha"/>
+        <a:font script="Syrc" typeface="Estrangelo Edessa"/>
+        <a:font script="Orya" typeface="Kalinga"/>
+        <a:font script="Mlym" typeface="Kartika"/>
+        <a:font script="Laoo" typeface="DokChampa"/>
+        <a:font script="Sinh" typeface="Iskoola Pota"/>
+        <a:font script="Mong" typeface="Mongolian Baiti"/>
+        <a:font script="Viet" typeface="Times New Roman"/>
+        <a:font script="Uigh" typeface="Microsoft Uighur"/>
+        <a:font script="Geor" typeface="Sylfaen"/>
+      </a:majorFont>
+      <a:minorFont>
+        <a:latin typeface="Arial"/>
+        <a:ea typeface=""/>
+        <a:cs typeface=""/>
+        <a:font script="Jpan" typeface="ＭＳ Ｐゴシック"/>
+        <a:font script="Hang" typeface="맑은 고딕"/>
+        <a:font script="Hans" typeface="宋体"/>
+        <a:font script="Hant" typeface="新細明體"/>
+        <a:font script="Arab" typeface="Arial"/>
+        <a:font script="Hebr" typeface="Arial"/>
+        <a:font script="Thai" typeface="Cordia New"/>
+        <a:font script="Ethi" typeface="Nyala"/>
+        <a:font script="Beng" typeface="Vrinda"/>
+        <a:font script="Gujr" typeface="Shruti"/>
+        <a:font script="Khmr" typeface="DaunPenh"/>
+        <a:font script="Knda" typeface="Tunga"/>
+        <a:font script="Guru" typeface="Raavi"/>
+        <a:font script="Cans" typeface="Euphemia"/>
+        <a:font script="Cher" typeface="Plantagenet Cherokee"/>
+        <a:font script="Yiii" typeface="Microsoft Yi Baiti"/>
+        <a:font script="Tibt" typeface="Microsoft Himalaya"/>
+        <a:font script="Thaa" typeface="MV Boli"/>
+        <a:font script="Deva" typeface="Mangal"/>
+        <a:font script="Telu" typeface="Gautami"/>
+        <a:font script="Taml" typeface="Latha"/>
+        <a:font script="Syrc" typeface="Estrangelo Edessa"/>
+        <a:font script="Orya" typeface="Kalinga"/>
+        <a:font script="Mlym" typeface="Kartika"/>
+        <a:font script="Laoo" typeface="DokChampa"/>
+        <a:font script="Sinh" typeface="Iskoola Pota"/>
+        <a:font script="Mong" typeface="Mongolian Baiti"/>
+        <a:font script="Viet" typeface="Arial"/>
+        <a:font script="Uigh" typeface="Microsoft Uighur"/>
+        <a:font script="Geor" typeface="Sylfaen"/>
+      </a:minorFont>
+    </a:fontScheme>
+    <a:fmtScheme name="Office">
+      <a:fillStyleLst>
+        <a:solidFill>
+          <a:schemeClr val="phClr"/>
+        </a:solidFill>
+        <a:gradFill rotWithShape="1">
+          <a:gsLst>
+            <a:gs pos="0">
+              <a:schemeClr val="phClr">
+                <a:tint val="50000"/>
+                <a:satMod val="300000"/>
+              </a:schemeClr>
+            </a:gs>
+            <a:gs pos="35000">
+              <a:schemeClr val="phClr">
+                <a:tint val="37000"/>
+                <a:satMod val="300000"/>
+              </a:schemeClr>
+            </a:gs>
+            <a:gs pos="100000">
+              <a:schemeClr val="phClr">
+                <a:tint val="15000"/>
+                <a:satMod val="350000"/>
+              </a:schemeClr>
+            </a:gs>
+          </a:gsLst>
+          <a:lin ang="16200000" scaled="1"/>
+        </a:gradFill>
+        <a:gradFill rotWithShape="1">
+          <a:gsLst>
+            <a:gs pos="0">
+              <a:schemeClr val="phClr">
+                <a:tint val="100000"/>
+                <a:shade val="100000"/>
+                <a:satMod val="130000"/>
+              </a:schemeClr>
+            </a:gs>
+            <a:gs pos="100000">
+              <a:schemeClr val="phClr">
+                <a:tint val="50000"/>
+                <a:shade val="100000"/>
+                <a:satMod val="350000"/>
+              </a:schemeClr>
+            </a:gs>
+          </a:gsLst>
+          <a:lin ang="16200000" scaled="0"/>
+        </a:gradFill>
+      </a:fillStyleLst>
+      <a:lnStyleLst>
+        <a:ln w="9525" cap="flat" cmpd="sng" algn="ctr">
+          <a:solidFill>
+            <a:schemeClr val="phClr">
+              <a:shade val="95000"/>
+              <a:satMod val="105000"/>
+            </a:schemeClr>
+          </a:solidFill>
+          <a:prstDash val="solid"/>
+        </a:ln>
+        <a:ln w="25400" cap="flat" cmpd="sng" algn="ctr">
+          <a:solidFill>
+            <a:schemeClr val="phClr"/>
+          </a:solidFill>
+          <a:prstDash val="solid"/>
+        </a:ln>
+        <a:ln w="38100" cap="flat" cmpd="sng" algn="ctr">
+          <a:solidFill>
+            <a:schemeClr val="phClr"/>
+          </a:solidFill>
+          <a:prstDash val="solid"/>
+        </a:ln>
+      </a:lnStyleLst>
+      <a:effectStyleLst>
+        <a:effectStyle>
+          <a:effectLst>
+            <a:outerShdw blurRad="40000" dist="20000" dir="5400000" rotWithShape="0">
+              <a:srgbClr val="000000">
+                <a:alpha val="38000"/>
+              </a:srgbClr>
+            </a:outerShdw>
+          </a:effectLst>
+        </a:effectStyle>
+        <a:effectStyle>
+          <a:effectLst>
+            <a:outerShdw blurRad="40000" dist="23000" dir="5400000" rotWithShape="0">
+              <a:srgbClr val="000000">
+                <a:alpha val="35000"/>
+              </a:srgbClr>
+            </a:outerShdw>
+          </a:effectLst>
+        </a:effectStyle>
+        <a:effectStyle>
+          <a:effectLst>
+            <a:outerShdw blurRad="40000" dist="23000" dir="5400000" rotWithShape="0">
+              <a:srgbClr val="000000">
+                <a:alpha val="35000"/>
+              </a:srgbClr>
+            </a:outerShdw>
+          </a:effectLst>
+          <a:scene3d>
+            <a:camera prst="orthographicFront">
+              <a:rot lat="0" lon="0" rev="0"/>
+            </a:camera>
+            <a:lightRig rig="threePt" dir="t">
+              <a:rot lat="0" lon="0" rev="1200000"/>
+            </a:lightRig>
+          </a:scene3d>
+          <a:sp3d>
+            <a:bevelT w="63500" h="25400"/>
+          </a:sp3d>
+        </a:effectStyle>
+      </a:effectStyleLst>
+      <a:bgFillStyleLst>
+        <a:solidFill>
+          <a:schemeClr val="phClr"/>
+        </a:solidFill>
+        <a:gradFill rotWithShape="1">
+          <a:gsLst>
+            <a:gs pos="0">
+              <a:schemeClr val="phClr">
+                <a:tint val="40000"/>
+                <a:satMod val="350000"/>
+              </a:schemeClr>
+            </a:gs>
+            <a:gs pos="40000">
+              <a:schemeClr val="phClr">
+                <a:tint val="45000"/>
+                <a:shade val="99000"/>
+                <a:satMod val="350000"/>
+              </a:schemeClr>
+            </a:gs>
+            <a:gs pos="100000">
+              <a:schemeClr val="phClr">
+                <a:shade val="20000"/>
+                <a:satMod val="255000"/>
+              </a:schemeClr>
+            </a:gs>
+          </a:gsLst>
+          <a:path path="circle">
+            <a:fillToRect l="50000" t="-80000" r="50000" b="180000"/>
+          </a:path>
+        </a:gradFill>
+        <a:gradFill rotWithShape="1">
+          <a:gsLst>
+            <a:gs pos="0">
+              <a:schemeClr val="phClr">
+                <a:tint val="80000"/>
+                <a:satMod val="300000"/>
+              </a:schemeClr>
+            </a:gs>
+            <a:gs pos="100000">
+              <a:schemeClr val="phClr">
+                <a:shade val="30000"/>
+                <a:satMod val="200000"/>
+              </a:schemeClr>
+            </a:gs>
+          </a:gsLst>
+          <a:path path="circle">
+            <a:fillToRect l="50000" t="50000" r="50000" b="50000"/>
+          </a:path>
+        </a:gradFill>
+      </a:bgFillStyleLst>
+    </a:fmtScheme>
+  </a:themeElements>
+</a:theme>
+</file>
+
+<file path=ppt/theme/theme2.xml><?xml version="1.0" encoding="utf-8"?>
 <a:theme xmlns:a="http://schemas.openxmlformats.org/drawingml/2006/main" xmlns:r="http://schemas.openxmlformats.org/officeDocument/2006/relationships">
   <a:themeElements>
     <a:clrScheme name="Default">
@@ -12729,283 +13008,4 @@
     </a:fmtScheme>
   </a:themeElements>
 </a:theme>
-</file>
-
-<file path=ppt/theme/theme2.xml><?xml version="1.0" encoding="utf-8"?>
-<a:theme xmlns:a="http://schemas.openxmlformats.org/drawingml/2006/main" xmlns:r="http://schemas.openxmlformats.org/officeDocument/2006/relationships" name="Simple Light">
-  <a:themeElements>
-    <a:clrScheme name="Simple Light">
-      <a:dk1>
-        <a:srgbClr val="000000"/>
-      </a:dk1>
-      <a:lt1>
-        <a:srgbClr val="FFFFFF"/>
-      </a:lt1>
-      <a:dk2>
-        <a:srgbClr val="595959"/>
-      </a:dk2>
-      <a:lt2>
-        <a:srgbClr val="EEEEEE"/>
-      </a:lt2>
-      <a:accent1>
-        <a:srgbClr val="4285F4"/>
-      </a:accent1>
-      <a:accent2>
-        <a:srgbClr val="212121"/>
-      </a:accent2>
-      <a:accent3>
-        <a:srgbClr val="78909C"/>
-      </a:accent3>
-      <a:accent4>
-        <a:srgbClr val="FFAB40"/>
-      </a:accent4>
-      <a:accent5>
-        <a:srgbClr val="0097A7"/>
-      </a:accent5>
-      <a:accent6>
-        <a:srgbClr val="EEFF41"/>
-      </a:accent6>
-      <a:hlink>
-        <a:srgbClr val="0097A7"/>
-      </a:hlink>
-      <a:folHlink>
-        <a:srgbClr val="0097A7"/>
-      </a:folHlink>
-    </a:clrScheme>
-    <a:fontScheme name="Office">
-      <a:majorFont>
-        <a:latin typeface="Arial"/>
-        <a:ea typeface=""/>
-        <a:cs typeface=""/>
-        <a:font script="Jpan" typeface="ＭＳ Ｐゴシック"/>
-        <a:font script="Hang" typeface="맑은 고딕"/>
-        <a:font script="Hans" typeface="宋体"/>
-        <a:font script="Hant" typeface="新細明體"/>
-        <a:font script="Arab" typeface="Times New Roman"/>
-        <a:font script="Hebr" typeface="Times New Roman"/>
-        <a:font script="Thai" typeface="Angsana New"/>
-        <a:font script="Ethi" typeface="Nyala"/>
-        <a:font script="Beng" typeface="Vrinda"/>
-        <a:font script="Gujr" typeface="Shruti"/>
-        <a:font script="Khmr" typeface="MoolBoran"/>
-        <a:font script="Knda" typeface="Tunga"/>
-        <a:font script="Guru" typeface="Raavi"/>
-        <a:font script="Cans" typeface="Euphemia"/>
-        <a:font script="Cher" typeface="Plantagenet Cherokee"/>
-        <a:font script="Yiii" typeface="Microsoft Yi Baiti"/>
-        <a:font script="Tibt" typeface="Microsoft Himalaya"/>
-        <a:font script="Thaa" typeface="MV Boli"/>
-        <a:font script="Deva" typeface="Mangal"/>
-        <a:font script="Telu" typeface="Gautami"/>
-        <a:font script="Taml" typeface="Latha"/>
-        <a:font script="Syrc" typeface="Estrangelo Edessa"/>
-        <a:font script="Orya" typeface="Kalinga"/>
-        <a:font script="Mlym" typeface="Kartika"/>
-        <a:font script="Laoo" typeface="DokChampa"/>
-        <a:font script="Sinh" typeface="Iskoola Pota"/>
-        <a:font script="Mong" typeface="Mongolian Baiti"/>
-        <a:font script="Viet" typeface="Times New Roman"/>
-        <a:font script="Uigh" typeface="Microsoft Uighur"/>
-        <a:font script="Geor" typeface="Sylfaen"/>
-      </a:majorFont>
-      <a:minorFont>
-        <a:latin typeface="Arial"/>
-        <a:ea typeface=""/>
-        <a:cs typeface=""/>
-        <a:font script="Jpan" typeface="ＭＳ Ｐゴシック"/>
-        <a:font script="Hang" typeface="맑은 고딕"/>
-        <a:font script="Hans" typeface="宋体"/>
-        <a:font script="Hant" typeface="新細明體"/>
-        <a:font script="Arab" typeface="Arial"/>
-        <a:font script="Hebr" typeface="Arial"/>
-        <a:font script="Thai" typeface="Cordia New"/>
-        <a:font script="Ethi" typeface="Nyala"/>
-        <a:font script="Beng" typeface="Vrinda"/>
-        <a:font script="Gujr" typeface="Shruti"/>
-        <a:font script="Khmr" typeface="DaunPenh"/>
-        <a:font script="Knda" typeface="Tunga"/>
-        <a:font script="Guru" typeface="Raavi"/>
-        <a:font script="Cans" typeface="Euphemia"/>
-        <a:font script="Cher" typeface="Plantagenet Cherokee"/>
-        <a:font script="Yiii" typeface="Microsoft Yi Baiti"/>
-        <a:font script="Tibt" typeface="Microsoft Himalaya"/>
-        <a:font script="Thaa" typeface="MV Boli"/>
-        <a:font script="Deva" typeface="Mangal"/>
-        <a:font script="Telu" typeface="Gautami"/>
-        <a:font script="Taml" typeface="Latha"/>
-        <a:font script="Syrc" typeface="Estrangelo Edessa"/>
-        <a:font script="Orya" typeface="Kalinga"/>
-        <a:font script="Mlym" typeface="Kartika"/>
-        <a:font script="Laoo" typeface="DokChampa"/>
-        <a:font script="Sinh" typeface="Iskoola Pota"/>
-        <a:font script="Mong" typeface="Mongolian Baiti"/>
-        <a:font script="Viet" typeface="Arial"/>
-        <a:font script="Uigh" typeface="Microsoft Uighur"/>
-        <a:font script="Geor" typeface="Sylfaen"/>
-      </a:minorFont>
-    </a:fontScheme>
-    <a:fmtScheme name="Office">
-      <a:fillStyleLst>
-        <a:solidFill>
-          <a:schemeClr val="phClr"/>
-        </a:solidFill>
-        <a:gradFill rotWithShape="1">
-          <a:gsLst>
-            <a:gs pos="0">
-              <a:schemeClr val="phClr">
-                <a:tint val="50000"/>
-                <a:satMod val="300000"/>
-              </a:schemeClr>
-            </a:gs>
-            <a:gs pos="35000">
-              <a:schemeClr val="phClr">
-                <a:tint val="37000"/>
-                <a:satMod val="300000"/>
-              </a:schemeClr>
-            </a:gs>
-            <a:gs pos="100000">
-              <a:schemeClr val="phClr">
-                <a:tint val="15000"/>
-                <a:satMod val="350000"/>
-              </a:schemeClr>
-            </a:gs>
-          </a:gsLst>
-          <a:lin ang="16200000" scaled="1"/>
-        </a:gradFill>
-        <a:gradFill rotWithShape="1">
-          <a:gsLst>
-            <a:gs pos="0">
-              <a:schemeClr val="phClr">
-                <a:tint val="100000"/>
-                <a:shade val="100000"/>
-                <a:satMod val="130000"/>
-              </a:schemeClr>
-            </a:gs>
-            <a:gs pos="100000">
-              <a:schemeClr val="phClr">
-                <a:tint val="50000"/>
-                <a:shade val="100000"/>
-                <a:satMod val="350000"/>
-              </a:schemeClr>
-            </a:gs>
-          </a:gsLst>
-          <a:lin ang="16200000" scaled="0"/>
-        </a:gradFill>
-      </a:fillStyleLst>
-      <a:lnStyleLst>
-        <a:ln w="9525" cap="flat" cmpd="sng" algn="ctr">
-          <a:solidFill>
-            <a:schemeClr val="phClr">
-              <a:shade val="95000"/>
-              <a:satMod val="105000"/>
-            </a:schemeClr>
-          </a:solidFill>
-          <a:prstDash val="solid"/>
-        </a:ln>
-        <a:ln w="25400" cap="flat" cmpd="sng" algn="ctr">
-          <a:solidFill>
-            <a:schemeClr val="phClr"/>
-          </a:solidFill>
-          <a:prstDash val="solid"/>
-        </a:ln>
-        <a:ln w="38100" cap="flat" cmpd="sng" algn="ctr">
-          <a:solidFill>
-            <a:schemeClr val="phClr"/>
-          </a:solidFill>
-          <a:prstDash val="solid"/>
-        </a:ln>
-      </a:lnStyleLst>
-      <a:effectStyleLst>
-        <a:effectStyle>
-          <a:effectLst>
-            <a:outerShdw blurRad="40000" dist="20000" dir="5400000" rotWithShape="0">
-              <a:srgbClr val="000000">
-                <a:alpha val="38000"/>
-              </a:srgbClr>
-            </a:outerShdw>
-          </a:effectLst>
-        </a:effectStyle>
-        <a:effectStyle>
-          <a:effectLst>
-            <a:outerShdw blurRad="40000" dist="23000" dir="5400000" rotWithShape="0">
-              <a:srgbClr val="000000">
-                <a:alpha val="35000"/>
-              </a:srgbClr>
-            </a:outerShdw>
-          </a:effectLst>
-        </a:effectStyle>
-        <a:effectStyle>
-          <a:effectLst>
-            <a:outerShdw blurRad="40000" dist="23000" dir="5400000" rotWithShape="0">
-              <a:srgbClr val="000000">
-                <a:alpha val="35000"/>
-              </a:srgbClr>
-            </a:outerShdw>
-          </a:effectLst>
-          <a:scene3d>
-            <a:camera prst="orthographicFront">
-              <a:rot lat="0" lon="0" rev="0"/>
-            </a:camera>
-            <a:lightRig rig="threePt" dir="t">
-              <a:rot lat="0" lon="0" rev="1200000"/>
-            </a:lightRig>
-          </a:scene3d>
-          <a:sp3d>
-            <a:bevelT w="63500" h="25400"/>
-          </a:sp3d>
-        </a:effectStyle>
-      </a:effectStyleLst>
-      <a:bgFillStyleLst>
-        <a:solidFill>
-          <a:schemeClr val="phClr"/>
-        </a:solidFill>
-        <a:gradFill rotWithShape="1">
-          <a:gsLst>
-            <a:gs pos="0">
-              <a:schemeClr val="phClr">
-                <a:tint val="40000"/>
-                <a:satMod val="350000"/>
-              </a:schemeClr>
-            </a:gs>
-            <a:gs pos="40000">
-              <a:schemeClr val="phClr">
-                <a:tint val="45000"/>
-                <a:shade val="99000"/>
-                <a:satMod val="350000"/>
-              </a:schemeClr>
-            </a:gs>
-            <a:gs pos="100000">
-              <a:schemeClr val="phClr">
-                <a:shade val="20000"/>
-                <a:satMod val="255000"/>
-              </a:schemeClr>
-            </a:gs>
-          </a:gsLst>
-          <a:path path="circle">
-            <a:fillToRect l="50000" t="-80000" r="50000" b="180000"/>
-          </a:path>
-        </a:gradFill>
-        <a:gradFill rotWithShape="1">
-          <a:gsLst>
-            <a:gs pos="0">
-              <a:schemeClr val="phClr">
-                <a:tint val="80000"/>
-                <a:satMod val="300000"/>
-              </a:schemeClr>
-            </a:gs>
-            <a:gs pos="100000">
-              <a:schemeClr val="phClr">
-                <a:shade val="30000"/>
-                <a:satMod val="200000"/>
-              </a:schemeClr>
-            </a:gs>
-          </a:gsLst>
-          <a:path path="circle">
-            <a:fillToRect l="50000" t="50000" r="50000" b="50000"/>
-          </a:path>
-        </a:gradFill>
-      </a:bgFillStyleLst>
-    </a:fmtScheme>
-  </a:themeElements>
-</a:theme>
 </file>
</xml_diff>

<commit_message>
docs: resync figure numbering from Drive decks (2026-09-30)
Pulled updated versions of all 4 Fig decks from Drive (MyM, R1, R2, R3).
Re-extracted slide text/images and compared against docs/mapping_figuras.csv:
content in every deck still matches its currently assigned figure numbers
and order, so no numero_actual changes were needed. Fig R3.pptx gained a
new empty placeholder slide (title+content, no images/text yet) after its
3 existing content slides - not yet resolvable to R3.3 or R3.4, flagged
for manual review rather than guessed.

Co-Authored-By: Claude Sonnet 5 <noreply@anthropic.com>
</commit_message>
<xml_diff>
--- a/docs/Fig MyM.pptx
+++ b/docs/Fig MyM.pptx
@@ -12453,6 +12453,285 @@
 </file>
 
 <file path=ppt/theme/theme1.xml><?xml version="1.0" encoding="utf-8"?>
+<a:theme xmlns:a="http://schemas.openxmlformats.org/drawingml/2006/main" xmlns:r="http://schemas.openxmlformats.org/officeDocument/2006/relationships">
+  <a:themeElements>
+    <a:clrScheme name="Default">
+      <a:dk1>
+        <a:srgbClr val="000000"/>
+      </a:dk1>
+      <a:lt1>
+        <a:srgbClr val="FFFFFF"/>
+      </a:lt1>
+      <a:dk2>
+        <a:srgbClr val="158158"/>
+      </a:dk2>
+      <a:lt2>
+        <a:srgbClr val="F3F3F3"/>
+      </a:lt2>
+      <a:accent1>
+        <a:srgbClr val="058DC7"/>
+      </a:accent1>
+      <a:accent2>
+        <a:srgbClr val="50B432"/>
+      </a:accent2>
+      <a:accent3>
+        <a:srgbClr val="ED561B"/>
+      </a:accent3>
+      <a:accent4>
+        <a:srgbClr val="EDEF00"/>
+      </a:accent4>
+      <a:accent5>
+        <a:srgbClr val="24CBE5"/>
+      </a:accent5>
+      <a:accent6>
+        <a:srgbClr val="64E572"/>
+      </a:accent6>
+      <a:hlink>
+        <a:srgbClr val="2200CC"/>
+      </a:hlink>
+      <a:folHlink>
+        <a:srgbClr val="551A8B"/>
+      </a:folHlink>
+    </a:clrScheme>
+    <a:fontScheme name="Office">
+      <a:majorFont>
+        <a:latin typeface="Arial"/>
+        <a:ea typeface=""/>
+        <a:cs typeface=""/>
+        <a:font script="Jpan" typeface="ＭＳ Ｐゴシック"/>
+        <a:font script="Hang" typeface="맑은 고딕"/>
+        <a:font script="Hans" typeface="宋体"/>
+        <a:font script="Hant" typeface="新細明體"/>
+        <a:font script="Arab" typeface="Times New Roman"/>
+        <a:font script="Hebr" typeface="Times New Roman"/>
+        <a:font script="Thai" typeface="Angsana New"/>
+        <a:font script="Ethi" typeface="Nyala"/>
+        <a:font script="Beng" typeface="Vrinda"/>
+        <a:font script="Gujr" typeface="Shruti"/>
+        <a:font script="Khmr" typeface="MoolBoran"/>
+        <a:font script="Knda" typeface="Tunga"/>
+        <a:font script="Guru" typeface="Raavi"/>
+        <a:font script="Cans" typeface="Euphemia"/>
+        <a:font script="Cher" typeface="Plantagenet Cherokee"/>
+        <a:font script="Yiii" typeface="Microsoft Yi Baiti"/>
+        <a:font script="Tibt" typeface="Microsoft Himalaya"/>
+        <a:font script="Thaa" typeface="MV Boli"/>
+        <a:font script="Deva" typeface="Mangal"/>
+        <a:font script="Telu" typeface="Gautami"/>
+        <a:font script="Taml" typeface="Latha"/>
+        <a:font script="Syrc" typeface="Estrangelo Edessa"/>
+        <a:font script="Orya" typeface="Kalinga"/>
+        <a:font script="Mlym" typeface="Kartika"/>
+        <a:font script="Laoo" typeface="DokChampa"/>
+        <a:font script="Sinh" typeface="Iskoola Pota"/>
+        <a:font script="Mong" typeface="Mongolian Baiti"/>
+        <a:font script="Viet" typeface="Times New Roman"/>
+        <a:font script="Uigh" typeface="Microsoft Uighur"/>
+        <a:font script="Geor" typeface="Sylfaen"/>
+      </a:majorFont>
+      <a:minorFont>
+        <a:latin typeface="Arial"/>
+        <a:ea typeface=""/>
+        <a:cs typeface=""/>
+        <a:font script="Jpan" typeface="ＭＳ Ｐゴシック"/>
+        <a:font script="Hang" typeface="맑은 고딕"/>
+        <a:font script="Hans" typeface="宋体"/>
+        <a:font script="Hant" typeface="新細明體"/>
+        <a:font script="Arab" typeface="Arial"/>
+        <a:font script="Hebr" typeface="Arial"/>
+        <a:font script="Thai" typeface="Cordia New"/>
+        <a:font script="Ethi" typeface="Nyala"/>
+        <a:font script="Beng" typeface="Vrinda"/>
+        <a:font script="Gujr" typeface="Shruti"/>
+        <a:font script="Khmr" typeface="DaunPenh"/>
+        <a:font script="Knda" typeface="Tunga"/>
+        <a:font script="Guru" typeface="Raavi"/>
+        <a:font script="Cans" typeface="Euphemia"/>
+        <a:font script="Cher" typeface="Plantagenet Cherokee"/>
+        <a:font script="Yiii" typeface="Microsoft Yi Baiti"/>
+        <a:font script="Tibt" typeface="Microsoft Himalaya"/>
+        <a:font script="Thaa" typeface="MV Boli"/>
+        <a:font script="Deva" typeface="Mangal"/>
+        <a:font script="Telu" typeface="Gautami"/>
+        <a:font script="Taml" typeface="Latha"/>
+        <a:font script="Syrc" typeface="Estrangelo Edessa"/>
+        <a:font script="Orya" typeface="Kalinga"/>
+        <a:font script="Mlym" typeface="Kartika"/>
+        <a:font script="Laoo" typeface="DokChampa"/>
+        <a:font script="Sinh" typeface="Iskoola Pota"/>
+        <a:font script="Mong" typeface="Mongolian Baiti"/>
+        <a:font script="Viet" typeface="Arial"/>
+        <a:font script="Uigh" typeface="Microsoft Uighur"/>
+        <a:font script="Geor" typeface="Sylfaen"/>
+      </a:minorFont>
+    </a:fontScheme>
+    <a:fmtScheme name="Office">
+      <a:fillStyleLst>
+        <a:solidFill>
+          <a:schemeClr val="phClr"/>
+        </a:solidFill>
+        <a:gradFill rotWithShape="1">
+          <a:gsLst>
+            <a:gs pos="0">
+              <a:schemeClr val="phClr">
+                <a:tint val="50000"/>
+                <a:satMod val="300000"/>
+              </a:schemeClr>
+            </a:gs>
+            <a:gs pos="35000">
+              <a:schemeClr val="phClr">
+                <a:tint val="37000"/>
+                <a:satMod val="300000"/>
+              </a:schemeClr>
+            </a:gs>
+            <a:gs pos="100000">
+              <a:schemeClr val="phClr">
+                <a:tint val="15000"/>
+                <a:satMod val="350000"/>
+              </a:schemeClr>
+            </a:gs>
+          </a:gsLst>
+          <a:lin ang="16200000" scaled="1"/>
+        </a:gradFill>
+        <a:gradFill rotWithShape="1">
+          <a:gsLst>
+            <a:gs pos="0">
+              <a:schemeClr val="phClr">
+                <a:tint val="100000"/>
+                <a:shade val="100000"/>
+                <a:satMod val="130000"/>
+              </a:schemeClr>
+            </a:gs>
+            <a:gs pos="100000">
+              <a:schemeClr val="phClr">
+                <a:tint val="50000"/>
+                <a:shade val="100000"/>
+                <a:satMod val="350000"/>
+              </a:schemeClr>
+            </a:gs>
+          </a:gsLst>
+          <a:lin ang="16200000" scaled="0"/>
+        </a:gradFill>
+      </a:fillStyleLst>
+      <a:lnStyleLst>
+        <a:ln w="9525" cap="flat" cmpd="sng" algn="ctr">
+          <a:solidFill>
+            <a:schemeClr val="phClr">
+              <a:shade val="95000"/>
+              <a:satMod val="105000"/>
+            </a:schemeClr>
+          </a:solidFill>
+          <a:prstDash val="solid"/>
+        </a:ln>
+        <a:ln w="25400" cap="flat" cmpd="sng" algn="ctr">
+          <a:solidFill>
+            <a:schemeClr val="phClr"/>
+          </a:solidFill>
+          <a:prstDash val="solid"/>
+        </a:ln>
+        <a:ln w="38100" cap="flat" cmpd="sng" algn="ctr">
+          <a:solidFill>
+            <a:schemeClr val="phClr"/>
+          </a:solidFill>
+          <a:prstDash val="solid"/>
+        </a:ln>
+      </a:lnStyleLst>
+      <a:effectStyleLst>
+        <a:effectStyle>
+          <a:effectLst>
+            <a:outerShdw blurRad="40000" dist="20000" dir="5400000" rotWithShape="0">
+              <a:srgbClr val="000000">
+                <a:alpha val="38000"/>
+              </a:srgbClr>
+            </a:outerShdw>
+          </a:effectLst>
+        </a:effectStyle>
+        <a:effectStyle>
+          <a:effectLst>
+            <a:outerShdw blurRad="40000" dist="23000" dir="5400000" rotWithShape="0">
+              <a:srgbClr val="000000">
+                <a:alpha val="35000"/>
+              </a:srgbClr>
+            </a:outerShdw>
+          </a:effectLst>
+        </a:effectStyle>
+        <a:effectStyle>
+          <a:effectLst>
+            <a:outerShdw blurRad="40000" dist="23000" dir="5400000" rotWithShape="0">
+              <a:srgbClr val="000000">
+                <a:alpha val="35000"/>
+              </a:srgbClr>
+            </a:outerShdw>
+          </a:effectLst>
+          <a:scene3d>
+            <a:camera prst="orthographicFront">
+              <a:rot lat="0" lon="0" rev="0"/>
+            </a:camera>
+            <a:lightRig rig="threePt" dir="t">
+              <a:rot lat="0" lon="0" rev="1200000"/>
+            </a:lightRig>
+          </a:scene3d>
+          <a:sp3d>
+            <a:bevelT w="63500" h="25400"/>
+          </a:sp3d>
+        </a:effectStyle>
+      </a:effectStyleLst>
+      <a:bgFillStyleLst>
+        <a:solidFill>
+          <a:schemeClr val="phClr"/>
+        </a:solidFill>
+        <a:gradFill rotWithShape="1">
+          <a:gsLst>
+            <a:gs pos="0">
+              <a:schemeClr val="phClr">
+                <a:tint val="40000"/>
+                <a:satMod val="350000"/>
+              </a:schemeClr>
+            </a:gs>
+            <a:gs pos="40000">
+              <a:schemeClr val="phClr">
+                <a:tint val="45000"/>
+                <a:shade val="99000"/>
+                <a:satMod val="350000"/>
+              </a:schemeClr>
+            </a:gs>
+            <a:gs pos="100000">
+              <a:schemeClr val="phClr">
+                <a:shade val="20000"/>
+                <a:satMod val="255000"/>
+              </a:schemeClr>
+            </a:gs>
+          </a:gsLst>
+          <a:path path="circle">
+            <a:fillToRect l="50000" t="-80000" r="50000" b="180000"/>
+          </a:path>
+        </a:gradFill>
+        <a:gradFill rotWithShape="1">
+          <a:gsLst>
+            <a:gs pos="0">
+              <a:schemeClr val="phClr">
+                <a:tint val="80000"/>
+                <a:satMod val="300000"/>
+              </a:schemeClr>
+            </a:gs>
+            <a:gs pos="100000">
+              <a:schemeClr val="phClr">
+                <a:shade val="30000"/>
+                <a:satMod val="200000"/>
+              </a:schemeClr>
+            </a:gs>
+          </a:gsLst>
+          <a:path path="circle">
+            <a:fillToRect l="50000" t="50000" r="50000" b="50000"/>
+          </a:path>
+        </a:gradFill>
+      </a:bgFillStyleLst>
+    </a:fmtScheme>
+  </a:themeElements>
+</a:theme>
+</file>
+
+<file path=ppt/theme/theme2.xml><?xml version="1.0" encoding="utf-8"?>
 <a:theme xmlns:a="http://schemas.openxmlformats.org/drawingml/2006/main" xmlns:r="http://schemas.openxmlformats.org/officeDocument/2006/relationships" name="Simple Light">
   <a:themeElements>
     <a:clrScheme name="Simple Light">
@@ -12729,283 +13008,4 @@
     </a:fmtScheme>
   </a:themeElements>
 </a:theme>
-</file>
-
-<file path=ppt/theme/theme2.xml><?xml version="1.0" encoding="utf-8"?>
-<a:theme xmlns:a="http://schemas.openxmlformats.org/drawingml/2006/main" xmlns:r="http://schemas.openxmlformats.org/officeDocument/2006/relationships">
-  <a:themeElements>
-    <a:clrScheme name="Default">
-      <a:dk1>
-        <a:srgbClr val="000000"/>
-      </a:dk1>
-      <a:lt1>
-        <a:srgbClr val="FFFFFF"/>
-      </a:lt1>
-      <a:dk2>
-        <a:srgbClr val="158158"/>
-      </a:dk2>
-      <a:lt2>
-        <a:srgbClr val="F3F3F3"/>
-      </a:lt2>
-      <a:accent1>
-        <a:srgbClr val="058DC7"/>
-      </a:accent1>
-      <a:accent2>
-        <a:srgbClr val="50B432"/>
-      </a:accent2>
-      <a:accent3>
-        <a:srgbClr val="ED561B"/>
-      </a:accent3>
-      <a:accent4>
-        <a:srgbClr val="EDEF00"/>
-      </a:accent4>
-      <a:accent5>
-        <a:srgbClr val="24CBE5"/>
-      </a:accent5>
-      <a:accent6>
-        <a:srgbClr val="64E572"/>
-      </a:accent6>
-      <a:hlink>
-        <a:srgbClr val="2200CC"/>
-      </a:hlink>
-      <a:folHlink>
-        <a:srgbClr val="551A8B"/>
-      </a:folHlink>
-    </a:clrScheme>
-    <a:fontScheme name="Office">
-      <a:majorFont>
-        <a:latin typeface="Arial"/>
-        <a:ea typeface=""/>
-        <a:cs typeface=""/>
-        <a:font script="Jpan" typeface="ＭＳ Ｐゴシック"/>
-        <a:font script="Hang" typeface="맑은 고딕"/>
-        <a:font script="Hans" typeface="宋体"/>
-        <a:font script="Hant" typeface="新細明體"/>
-        <a:font script="Arab" typeface="Times New Roman"/>
-        <a:font script="Hebr" typeface="Times New Roman"/>
-        <a:font script="Thai" typeface="Angsana New"/>
-        <a:font script="Ethi" typeface="Nyala"/>
-        <a:font script="Beng" typeface="Vrinda"/>
-        <a:font script="Gujr" typeface="Shruti"/>
-        <a:font script="Khmr" typeface="MoolBoran"/>
-        <a:font script="Knda" typeface="Tunga"/>
-        <a:font script="Guru" typeface="Raavi"/>
-        <a:font script="Cans" typeface="Euphemia"/>
-        <a:font script="Cher" typeface="Plantagenet Cherokee"/>
-        <a:font script="Yiii" typeface="Microsoft Yi Baiti"/>
-        <a:font script="Tibt" typeface="Microsoft Himalaya"/>
-        <a:font script="Thaa" typeface="MV Boli"/>
-        <a:font script="Deva" typeface="Mangal"/>
-        <a:font script="Telu" typeface="Gautami"/>
-        <a:font script="Taml" typeface="Latha"/>
-        <a:font script="Syrc" typeface="Estrangelo Edessa"/>
-        <a:font script="Orya" typeface="Kalinga"/>
-        <a:font script="Mlym" typeface="Kartika"/>
-        <a:font script="Laoo" typeface="DokChampa"/>
-        <a:font script="Sinh" typeface="Iskoola Pota"/>
-        <a:font script="Mong" typeface="Mongolian Baiti"/>
-        <a:font script="Viet" typeface="Times New Roman"/>
-        <a:font script="Uigh" typeface="Microsoft Uighur"/>
-        <a:font script="Geor" typeface="Sylfaen"/>
-      </a:majorFont>
-      <a:minorFont>
-        <a:latin typeface="Arial"/>
-        <a:ea typeface=""/>
-        <a:cs typeface=""/>
-        <a:font script="Jpan" typeface="ＭＳ Ｐゴシック"/>
-        <a:font script="Hang" typeface="맑은 고딕"/>
-        <a:font script="Hans" typeface="宋体"/>
-        <a:font script="Hant" typeface="新細明體"/>
-        <a:font script="Arab" typeface="Arial"/>
-        <a:font script="Hebr" typeface="Arial"/>
-        <a:font script="Thai" typeface="Cordia New"/>
-        <a:font script="Ethi" typeface="Nyala"/>
-        <a:font script="Beng" typeface="Vrinda"/>
-        <a:font script="Gujr" typeface="Shruti"/>
-        <a:font script="Khmr" typeface="DaunPenh"/>
-        <a:font script="Knda" typeface="Tunga"/>
-        <a:font script="Guru" typeface="Raavi"/>
-        <a:font script="Cans" typeface="Euphemia"/>
-        <a:font script="Cher" typeface="Plantagenet Cherokee"/>
-        <a:font script="Yiii" typeface="Microsoft Yi Baiti"/>
-        <a:font script="Tibt" typeface="Microsoft Himalaya"/>
-        <a:font script="Thaa" typeface="MV Boli"/>
-        <a:font script="Deva" typeface="Mangal"/>
-        <a:font script="Telu" typeface="Gautami"/>
-        <a:font script="Taml" typeface="Latha"/>
-        <a:font script="Syrc" typeface="Estrangelo Edessa"/>
-        <a:font script="Orya" typeface="Kalinga"/>
-        <a:font script="Mlym" typeface="Kartika"/>
-        <a:font script="Laoo" typeface="DokChampa"/>
-        <a:font script="Sinh" typeface="Iskoola Pota"/>
-        <a:font script="Mong" typeface="Mongolian Baiti"/>
-        <a:font script="Viet" typeface="Arial"/>
-        <a:font script="Uigh" typeface="Microsoft Uighur"/>
-        <a:font script="Geor" typeface="Sylfaen"/>
-      </a:minorFont>
-    </a:fontScheme>
-    <a:fmtScheme name="Office">
-      <a:fillStyleLst>
-        <a:solidFill>
-          <a:schemeClr val="phClr"/>
-        </a:solidFill>
-        <a:gradFill rotWithShape="1">
-          <a:gsLst>
-            <a:gs pos="0">
-              <a:schemeClr val="phClr">
-                <a:tint val="50000"/>
-                <a:satMod val="300000"/>
-              </a:schemeClr>
-            </a:gs>
-            <a:gs pos="35000">
-              <a:schemeClr val="phClr">
-                <a:tint val="37000"/>
-                <a:satMod val="300000"/>
-              </a:schemeClr>
-            </a:gs>
-            <a:gs pos="100000">
-              <a:schemeClr val="phClr">
-                <a:tint val="15000"/>
-                <a:satMod val="350000"/>
-              </a:schemeClr>
-            </a:gs>
-          </a:gsLst>
-          <a:lin ang="16200000" scaled="1"/>
-        </a:gradFill>
-        <a:gradFill rotWithShape="1">
-          <a:gsLst>
-            <a:gs pos="0">
-              <a:schemeClr val="phClr">
-                <a:tint val="100000"/>
-                <a:shade val="100000"/>
-                <a:satMod val="130000"/>
-              </a:schemeClr>
-            </a:gs>
-            <a:gs pos="100000">
-              <a:schemeClr val="phClr">
-                <a:tint val="50000"/>
-                <a:shade val="100000"/>
-                <a:satMod val="350000"/>
-              </a:schemeClr>
-            </a:gs>
-          </a:gsLst>
-          <a:lin ang="16200000" scaled="0"/>
-        </a:gradFill>
-      </a:fillStyleLst>
-      <a:lnStyleLst>
-        <a:ln w="9525" cap="flat" cmpd="sng" algn="ctr">
-          <a:solidFill>
-            <a:schemeClr val="phClr">
-              <a:shade val="95000"/>
-              <a:satMod val="105000"/>
-            </a:schemeClr>
-          </a:solidFill>
-          <a:prstDash val="solid"/>
-        </a:ln>
-        <a:ln w="25400" cap="flat" cmpd="sng" algn="ctr">
-          <a:solidFill>
-            <a:schemeClr val="phClr"/>
-          </a:solidFill>
-          <a:prstDash val="solid"/>
-        </a:ln>
-        <a:ln w="38100" cap="flat" cmpd="sng" algn="ctr">
-          <a:solidFill>
-            <a:schemeClr val="phClr"/>
-          </a:solidFill>
-          <a:prstDash val="solid"/>
-        </a:ln>
-      </a:lnStyleLst>
-      <a:effectStyleLst>
-        <a:effectStyle>
-          <a:effectLst>
-            <a:outerShdw blurRad="40000" dist="20000" dir="5400000" rotWithShape="0">
-              <a:srgbClr val="000000">
-                <a:alpha val="38000"/>
-              </a:srgbClr>
-            </a:outerShdw>
-          </a:effectLst>
-        </a:effectStyle>
-        <a:effectStyle>
-          <a:effectLst>
-            <a:outerShdw blurRad="40000" dist="23000" dir="5400000" rotWithShape="0">
-              <a:srgbClr val="000000">
-                <a:alpha val="35000"/>
-              </a:srgbClr>
-            </a:outerShdw>
-          </a:effectLst>
-        </a:effectStyle>
-        <a:effectStyle>
-          <a:effectLst>
-            <a:outerShdw blurRad="40000" dist="23000" dir="5400000" rotWithShape="0">
-              <a:srgbClr val="000000">
-                <a:alpha val="35000"/>
-              </a:srgbClr>
-            </a:outerShdw>
-          </a:effectLst>
-          <a:scene3d>
-            <a:camera prst="orthographicFront">
-              <a:rot lat="0" lon="0" rev="0"/>
-            </a:camera>
-            <a:lightRig rig="threePt" dir="t">
-              <a:rot lat="0" lon="0" rev="1200000"/>
-            </a:lightRig>
-          </a:scene3d>
-          <a:sp3d>
-            <a:bevelT w="63500" h="25400"/>
-          </a:sp3d>
-        </a:effectStyle>
-      </a:effectStyleLst>
-      <a:bgFillStyleLst>
-        <a:solidFill>
-          <a:schemeClr val="phClr"/>
-        </a:solidFill>
-        <a:gradFill rotWithShape="1">
-          <a:gsLst>
-            <a:gs pos="0">
-              <a:schemeClr val="phClr">
-                <a:tint val="40000"/>
-                <a:satMod val="350000"/>
-              </a:schemeClr>
-            </a:gs>
-            <a:gs pos="40000">
-              <a:schemeClr val="phClr">
-                <a:tint val="45000"/>
-                <a:shade val="99000"/>
-                <a:satMod val="350000"/>
-              </a:schemeClr>
-            </a:gs>
-            <a:gs pos="100000">
-              <a:schemeClr val="phClr">
-                <a:shade val="20000"/>
-                <a:satMod val="255000"/>
-              </a:schemeClr>
-            </a:gs>
-          </a:gsLst>
-          <a:path path="circle">
-            <a:fillToRect l="50000" t="-80000" r="50000" b="180000"/>
-          </a:path>
-        </a:gradFill>
-        <a:gradFill rotWithShape="1">
-          <a:gsLst>
-            <a:gs pos="0">
-              <a:schemeClr val="phClr">
-                <a:tint val="80000"/>
-                <a:satMod val="300000"/>
-              </a:schemeClr>
-            </a:gs>
-            <a:gs pos="100000">
-              <a:schemeClr val="phClr">
-                <a:shade val="30000"/>
-                <a:satMod val="200000"/>
-              </a:schemeClr>
-            </a:gs>
-          </a:gsLst>
-          <a:path path="circle">
-            <a:fillToRect l="50000" t="50000" r="50000" b="50000"/>
-          </a:path>
-        </a:gradFill>
-      </a:bgFillStyleLst>
-    </a:fmtScheme>
-  </a:themeElements>
-</a:theme>
 </file>
</xml_diff>